<commit_message>
Track 2 deep dive: structural mechanism (domain map, PDB+AF distances), RMS trial landscape, deck+notebook updates
</commit_message>
<xml_diff>
--- a/track2/slides/pitch_deck.pptx
+++ b/track2/slides/pitch_deck.pptx
@@ -12,6 +12,7 @@
     <p:sldId id="260" r:id="rId11"/>
     <p:sldId id="261" r:id="rId12"/>
     <p:sldId id="262" r:id="rId13"/>
+    <p:sldId id="267" r:id="rId18"/>
     <p:sldId id="263" r:id="rId14"/>
     <p:sldId id="264" r:id="rId15"/>
     <p:sldId id="265" r:id="rId16"/>
@@ -3392,6 +3393,77 @@
           </a:p>
         </p:txBody>
       </p:sp>
+    </p:spTree>
+  </p:cSld>
+  <p:clrMapOvr>
+    <a:masterClrMapping/>
+  </p:clrMapOvr>
+</p:sld>
+</file>
+
+<file path=ppt/slides/slide12.xml><?xml version="1.0" encoding="utf-8"?>
+<p:sld xmlns:a="http://schemas.openxmlformats.org/drawingml/2006/main" xmlns:p="http://schemas.openxmlformats.org/presentationml/2006/main" xmlns:r="http://schemas.openxmlformats.org/officeDocument/2006/relationships">
+  <p:cSld>
+    <p:spTree>
+      <p:nvGrpSpPr>
+        <p:cNvPr id="1" name=""/>
+        <p:cNvGrpSpPr/>
+        <p:nvPr/>
+      </p:nvGrpSpPr>
+      <p:grpSpPr/>
+      <p:sp>
+        <p:nvSpPr>
+          <p:cNvPr id="2" name="TextBox 1"/>
+          <p:cNvSpPr txBox="1"/>
+          <p:nvPr/>
+        </p:nvSpPr>
+        <p:spPr>
+          <a:xfrm>
+            <a:off x="457200" y="274320"/>
+            <a:ext cx="11247120" cy="822960"/>
+          </a:xfrm>
+          <a:prstGeom prst="rect">
+            <a:avLst/>
+          </a:prstGeom>
+          <a:noFill/>
+        </p:spPr>
+        <p:txBody>
+          <a:bodyPr wrap="none">
+            <a:spAutoFit/>
+          </a:bodyPr>
+          <a:lstStyle/>
+          <a:p>
+            <a:r>
+              <a:rPr sz="2800" b="1"/>
+              <a:t>Both alleles hit the kinase domain — the scaffold survives</a:t>
+            </a:r>
+          </a:p>
+        </p:txBody>
+      </p:sp>
+      <p:pic>
+        <p:nvPicPr>
+          <p:cNvPr id="3" name="Picture 2" descr="fig_domainmap.png"/>
+          <p:cNvPicPr>
+            <a:picLocks noChangeAspect="1"/>
+          </p:cNvPicPr>
+          <p:nvPr/>
+        </p:nvPicPr>
+        <p:blipFill>
+          <a:blip r:embed="rId2"/>
+          <a:stretch>
+            <a:fillRect/>
+          </a:stretch>
+        </p:blipFill>
+        <p:spPr>
+          <a:xfrm>
+            <a:off x="914400" y="1188720"/>
+            <a:ext cx="10332720" cy="4133088"/>
+          </a:xfrm>
+          <a:prstGeom prst="rect">
+            <a:avLst/>
+          </a:prstGeom>
+        </p:spPr>
+      </p:pic>
     </p:spTree>
   </p:cSld>
   <p:clrMapOvr>

</xml_diff>

<commit_message>
Rewrite reports and decks in Simplified Technical English; rebuild figures
Fix overlapping domain-map labels, remove marketing metaphors from slides
and the video script, and plot Exomiser ranks from the genome-wide TSV.
</commit_message>
<xml_diff>
--- a/track2/slides/pitch_deck.pptx
+++ b/track2/slides/pitch_deck.pptx
@@ -12,11 +12,11 @@
     <p:sldId id="260" r:id="rId11"/>
     <p:sldId id="261" r:id="rId12"/>
     <p:sldId id="262" r:id="rId13"/>
-    <p:sldId id="267" r:id="rId18"/>
     <p:sldId id="263" r:id="rId14"/>
     <p:sldId id="264" r:id="rId15"/>
     <p:sldId id="265" r:id="rId16"/>
     <p:sldId id="266" r:id="rId17"/>
+    <p:sldId id="267" r:id="rId18"/>
   </p:sldIdLst>
   <p:sldSz cx="12191695" cy="6858000" type="screen4x3"/>
   <p:notesSz cx="6858000" cy="9144000"/>
@@ -3107,8 +3107,8 @@
         </p:nvSpPr>
         <p:spPr>
           <a:xfrm>
-            <a:off x="457200" y="274320"/>
-            <a:ext cx="11247120" cy="822960"/>
+            <a:off x="502920" y="256032"/>
+            <a:ext cx="11155680" cy="640080"/>
           </a:xfrm>
           <a:prstGeom prst="rect">
             <a:avLst/>
@@ -3121,9 +3121,15 @@
           </a:bodyPr>
           <a:lstStyle/>
           <a:p>
-            <a:r>
-              <a:rPr sz="3000" b="1"/>
-              <a:t>A real kid. A broken checkpoint. A three-tier plan.</a:t>
+            <a:pPr algn="l"/>
+            <a:r>
+              <a:rPr sz="2800" b="1">
+                <a:solidFill>
+                  <a:srgbClr val="1E3A5F"/>
+                </a:solidFill>
+                <a:latin typeface="Calibri"/>
+              </a:rPr>
+              <a:t>A real child. A checkpoint that does not work. A three-tier plan.</a:t>
             </a:r>
           </a:p>
         </p:txBody>
@@ -3136,8 +3142,8 @@
         </p:nvSpPr>
         <p:spPr>
           <a:xfrm>
-            <a:off x="731520" y="1463040"/>
-            <a:ext cx="10698480" cy="5029200"/>
+            <a:off x="640080" y="1463040"/>
+            <a:ext cx="10881360" cy="4754880"/>
           </a:xfrm>
           <a:prstGeom prst="rect">
             <a:avLst/>
@@ -3145,42 +3151,56 @@
           <a:noFill/>
         </p:spPr>
         <p:txBody>
-          <a:bodyPr wrap="none">
+          <a:bodyPr wrap="square">
             <a:spAutoFit/>
           </a:bodyPr>
           <a:lstStyle/>
-          <a:p/>
           <a:p>
             <a:pPr>
               <a:spcAft>
-                <a:spcPts val="1400"/>
+                <a:spcPts val="1200"/>
               </a:spcAft>
             </a:pPr>
             <a:r>
-              <a:rPr sz="2000"/>
-              <a:t>Mosaic Variegated Aneuploidy (MVA) — chromosomes lost and gained cell by cell</a:t>
+              <a:rPr sz="2200" b="0">
+                <a:solidFill>
+                  <a:srgbClr val="1A1A1A"/>
+                </a:solidFill>
+                <a:latin typeface="Calibri"/>
+              </a:rPr>
+              <a:t>Mosaic Variegated Aneuploidy (MVA). Cells lose and gain chromosomes.</a:t>
             </a:r>
           </a:p>
           <a:p>
             <a:pPr>
               <a:spcAft>
-                <a:spcPts val="1400"/>
+                <a:spcPts val="1200"/>
               </a:spcAft>
             </a:pPr>
             <a:r>
-              <a:rPr sz="2000"/>
-              <a:t>Embryonal rhabdomyosarcoma survivor · severe growth failure · nephrocalcinosis</a:t>
+              <a:rPr sz="2200" b="0">
+                <a:solidFill>
+                  <a:srgbClr val="1A1A1A"/>
+                </a:solidFill>
+                <a:latin typeface="Calibri"/>
+              </a:rPr>
+              <a:t>Embryonal rhabdomyosarcoma. Severe growth failure. Nephrocalcinosis.</a:t>
             </a:r>
           </a:p>
           <a:p>
             <a:pPr>
               <a:spcAft>
-                <a:spcPts val="1400"/>
+                <a:spcPts val="1200"/>
               </a:spcAft>
             </a:pPr>
             <a:r>
-              <a:rPr sz="2000"/>
-              <a:t>Team bigbag — Rare Disease, Real Kid: MVA Hackathon 2026</a:t>
+              <a:rPr sz="2200" b="0">
+                <a:solidFill>
+                  <a:srgbClr val="1A1A1A"/>
+                </a:solidFill>
+                <a:latin typeface="Calibri"/>
+              </a:rPr>
+              <a:t>Team bigbag. Rare Disease, Real Kid: MVA Hackathon 2026.</a:t>
             </a:r>
           </a:p>
         </p:txBody>
@@ -3211,8 +3231,8 @@
         </p:nvSpPr>
         <p:spPr>
           <a:xfrm>
-            <a:off x="457200" y="274320"/>
-            <a:ext cx="11247120" cy="822960"/>
+            <a:off x="502920" y="256032"/>
+            <a:ext cx="11155680" cy="640080"/>
           </a:xfrm>
           <a:prstGeom prst="rect">
             <a:avLst/>
@@ -3225,9 +3245,15 @@
           </a:bodyPr>
           <a:lstStyle/>
           <a:p>
-            <a:r>
-              <a:rPr sz="3000" b="1"/>
-              <a:t>The ask</a:t>
+            <a:pPr algn="l"/>
+            <a:r>
+              <a:rPr sz="2800" b="1">
+                <a:solidFill>
+                  <a:srgbClr val="1E3A5F"/>
+                </a:solidFill>
+                <a:latin typeface="Calibri"/>
+              </a:rPr>
+              <a:t>Scale. A laptop runs the pipeline.</a:t>
             </a:r>
           </a:p>
         </p:txBody>
@@ -3240,8 +3266,8 @@
         </p:nvSpPr>
         <p:spPr>
           <a:xfrm>
-            <a:off x="731520" y="1463040"/>
-            <a:ext cx="10698480" cy="5029200"/>
+            <a:off x="640080" y="1554480"/>
+            <a:ext cx="10881360" cy="4754880"/>
           </a:xfrm>
           <a:prstGeom prst="rect">
             <a:avLst/>
@@ -3249,53 +3275,72 @@
           <a:noFill/>
         </p:spPr>
         <p:txBody>
-          <a:bodyPr wrap="none">
+          <a:bodyPr wrap="square">
             <a:spAutoFit/>
           </a:bodyPr>
           <a:lstStyle/>
-          <a:p/>
           <a:p>
             <a:pPr>
               <a:spcAft>
-                <a:spcPts val="1400"/>
+                <a:spcPts val="1200"/>
               </a:spcAft>
             </a:pPr>
             <a:r>
-              <a:rPr sz="2000"/>
-              <a:t>Standard symptom care now</a:t>
+              <a:rPr sz="2200" b="0">
+                <a:solidFill>
+                  <a:srgbClr val="1A1A1A"/>
+                </a:solidFill>
+                <a:latin typeface="Calibri"/>
+              </a:rPr>
+              <a:t>Open Targets. DGIdb. ChEMBL. everycure/matrix-scores (39.5 million pairs). All public APIs.</a:t>
             </a:r>
           </a:p>
           <a:p>
             <a:pPr>
               <a:spcAft>
-                <a:spcPts val="1400"/>
+                <a:spcPts val="1200"/>
               </a:spcAft>
             </a:pPr>
             <a:r>
-              <a:rPr sz="2000"/>
-              <a:t>Trial-governed cancer options when needed</a:t>
+              <a:rPr sz="2200" b="0">
+                <a:solidFill>
+                  <a:srgbClr val="1A1A1A"/>
+                </a:solidFill>
+                <a:latin typeface="Calibri"/>
+              </a:rPr>
+              <a:t>Full pipeline: about 6 hours and 1 USD of electricity. Genome-wide check: 94 seconds.</a:t>
             </a:r>
           </a:p>
           <a:p>
             <a:pPr>
               <a:spcAft>
-                <a:spcPts val="1400"/>
+                <a:spcPts val="1200"/>
               </a:spcAft>
             </a:pPr>
             <a:r>
-              <a:rPr sz="2000"/>
-              <a:t>A serious research push on BubR1 restoration</a:t>
+              <a:rPr sz="2200" b="0">
+                <a:solidFill>
+                  <a:srgbClr val="1A1A1A"/>
+                </a:solidFill>
+                <a:latin typeface="Calibri"/>
+              </a:rPr>
+              <a:t>The method applies to other recessive chromosomal-instability disorders.</a:t>
             </a:r>
           </a:p>
           <a:p>
             <a:pPr>
               <a:spcAft>
-                <a:spcPts val="1400"/>
+                <a:spcPts val="1200"/>
               </a:spcAft>
             </a:pPr>
             <a:r>
-              <a:rPr sz="2000"/>
-              <a:t>This family shared their child's genome with the world — give them a path.</a:t>
+              <a:rPr sz="2200" b="0">
+                <a:solidFill>
+                  <a:srgbClr val="1A1A1A"/>
+                </a:solidFill>
+                <a:latin typeface="Calibri"/>
+              </a:rPr>
+              <a:t>Code and evidence: github.com/bigbag/mva-hackathon-2026</a:t>
             </a:r>
           </a:p>
         </p:txBody>
@@ -3326,8 +3371,8 @@
         </p:nvSpPr>
         <p:spPr>
           <a:xfrm>
-            <a:off x="457200" y="274320"/>
-            <a:ext cx="11247120" cy="822960"/>
+            <a:off x="502920" y="256032"/>
+            <a:ext cx="11155680" cy="640080"/>
           </a:xfrm>
           <a:prstGeom prst="rect">
             <a:avLst/>
@@ -3340,9 +3385,15 @@
           </a:bodyPr>
           <a:lstStyle/>
           <a:p>
-            <a:r>
-              <a:rPr sz="3000" b="1"/>
-              <a:t>Thank you</a:t>
+            <a:pPr algn="l"/>
+            <a:r>
+              <a:rPr sz="2800" b="1">
+                <a:solidFill>
+                  <a:srgbClr val="1E3A5F"/>
+                </a:solidFill>
+                <a:latin typeface="Calibri"/>
+              </a:rPr>
+              <a:t>The request</a:t>
             </a:r>
           </a:p>
         </p:txBody>
@@ -3355,8 +3406,8 @@
         </p:nvSpPr>
         <p:spPr>
           <a:xfrm>
-            <a:off x="731520" y="1463040"/>
-            <a:ext cx="10698480" cy="5029200"/>
+            <a:off x="640080" y="1554480"/>
+            <a:ext cx="10881360" cy="4754880"/>
           </a:xfrm>
           <a:prstGeom prst="rect">
             <a:avLst/>
@@ -3364,31 +3415,72 @@
           <a:noFill/>
         </p:spPr>
         <p:txBody>
-          <a:bodyPr wrap="none">
+          <a:bodyPr wrap="square">
             <a:spAutoFit/>
           </a:bodyPr>
           <a:lstStyle/>
-          <a:p/>
           <a:p>
             <a:pPr>
               <a:spcAft>
-                <a:spcPts val="1400"/>
+                <a:spcPts val="1200"/>
               </a:spcAft>
             </a:pPr>
             <a:r>
-              <a:rPr sz="2000"/>
-              <a:t>Team bigbag · github.com/bigbag/mva-hackathon-2026</a:t>
+              <a:rPr sz="2400" b="0">
+                <a:solidFill>
+                  <a:srgbClr val="1A1A1A"/>
+                </a:solidFill>
+                <a:latin typeface="Calibri"/>
+              </a:rPr>
+              <a:t>Give standard symptom care now.</a:t>
             </a:r>
           </a:p>
           <a:p>
             <a:pPr>
               <a:spcAft>
-                <a:spcPts val="1400"/>
+                <a:spcPts val="1200"/>
               </a:spcAft>
             </a:pPr>
             <a:r>
-              <a:rPr sz="2000"/>
-              <a:t>Acknowledgement per hackathon rules: Sage Bionetworks · MVA Society · HF · BEACON · AWS · Anthropic — and the family.</a:t>
+              <a:rPr sz="2400" b="0">
+                <a:solidFill>
+                  <a:srgbClr val="1A1A1A"/>
+                </a:solidFill>
+                <a:latin typeface="Calibri"/>
+              </a:rPr>
+              <a:t>Use trial-controlled cancer options when needed.</a:t>
+            </a:r>
+          </a:p>
+          <a:p>
+            <a:pPr>
+              <a:spcAft>
+                <a:spcPts val="1200"/>
+              </a:spcAft>
+            </a:pPr>
+            <a:r>
+              <a:rPr sz="2400" b="0">
+                <a:solidFill>
+                  <a:srgbClr val="1A1A1A"/>
+                </a:solidFill>
+                <a:latin typeface="Calibri"/>
+              </a:rPr>
+              <a:t>Start a research program on BubR1 restoration.</a:t>
+            </a:r>
+          </a:p>
+          <a:p>
+            <a:pPr>
+              <a:spcAft>
+                <a:spcPts val="1200"/>
+              </a:spcAft>
+            </a:pPr>
+            <a:r>
+              <a:rPr sz="2400" b="0">
+                <a:solidFill>
+                  <a:srgbClr val="1A1A1A"/>
+                </a:solidFill>
+                <a:latin typeface="Calibri"/>
+              </a:rPr>
+              <a:t>This family shared the genome of their child. We give them a clear plan.</a:t>
             </a:r>
           </a:p>
         </p:txBody>
@@ -3419,8 +3511,8 @@
         </p:nvSpPr>
         <p:spPr>
           <a:xfrm>
-            <a:off x="457200" y="274320"/>
-            <a:ext cx="11247120" cy="822960"/>
+            <a:off x="502920" y="256032"/>
+            <a:ext cx="11155680" cy="640080"/>
           </a:xfrm>
           <a:prstGeom prst="rect">
             <a:avLst/>
@@ -3433,37 +3525,106 @@
           </a:bodyPr>
           <a:lstStyle/>
           <a:p>
-            <a:r>
-              <a:rPr sz="2800" b="1"/>
-              <a:t>Both alleles hit the kinase domain — the scaffold survives</a:t>
-            </a:r>
-          </a:p>
-        </p:txBody>
-      </p:sp>
-      <p:pic>
-        <p:nvPicPr>
-          <p:cNvPr id="3" name="Picture 2" descr="fig_domainmap.png"/>
-          <p:cNvPicPr>
-            <a:picLocks noChangeAspect="1"/>
-          </p:cNvPicPr>
+            <a:pPr algn="l"/>
+            <a:r>
+              <a:rPr sz="2800" b="1">
+                <a:solidFill>
+                  <a:srgbClr val="1E3A5F"/>
+                </a:solidFill>
+                <a:latin typeface="Calibri"/>
+              </a:rPr>
+              <a:t>Thank you</a:t>
+            </a:r>
+          </a:p>
+        </p:txBody>
+      </p:sp>
+      <p:sp>
+        <p:nvSpPr>
+          <p:cNvPr id="3" name="TextBox 2"/>
+          <p:cNvSpPr txBox="1"/>
           <p:nvPr/>
-        </p:nvPicPr>
-        <p:blipFill>
-          <a:blip r:embed="rId2"/>
-          <a:stretch>
-            <a:fillRect/>
-          </a:stretch>
-        </p:blipFill>
-        <p:spPr>
-          <a:xfrm>
-            <a:off x="914400" y="1188720"/>
-            <a:ext cx="10332720" cy="4133088"/>
+        </p:nvSpPr>
+        <p:spPr>
+          <a:xfrm>
+            <a:off x="640080" y="1645920"/>
+            <a:ext cx="10881360" cy="4754880"/>
           </a:xfrm>
           <a:prstGeom prst="rect">
             <a:avLst/>
           </a:prstGeom>
-        </p:spPr>
-      </p:pic>
+          <a:noFill/>
+        </p:spPr>
+        <p:txBody>
+          <a:bodyPr wrap="square">
+            <a:spAutoFit/>
+          </a:bodyPr>
+          <a:lstStyle/>
+          <a:p>
+            <a:pPr>
+              <a:spcAft>
+                <a:spcPts val="1200"/>
+              </a:spcAft>
+            </a:pPr>
+            <a:r>
+              <a:rPr sz="2200" b="0">
+                <a:solidFill>
+                  <a:srgbClr val="1A1A1A"/>
+                </a:solidFill>
+                <a:latin typeface="Calibri"/>
+              </a:rPr>
+              <a:t>Team bigbag. github.com/bigbag/mva-hackathon-2026</a:t>
+            </a:r>
+          </a:p>
+          <a:p>
+            <a:pPr>
+              <a:spcAft>
+                <a:spcPts val="1200"/>
+              </a:spcAft>
+            </a:pPr>
+            <a:r>
+              <a:rPr sz="2200" b="0">
+                <a:solidFill>
+                  <a:srgbClr val="1A1A1A"/>
+                </a:solidFill>
+                <a:latin typeface="Calibri"/>
+              </a:rPr>
+              <a:t>Organizers: Sage Bionetworks, MVA Society, Hugging Face, BEACON.</a:t>
+            </a:r>
+          </a:p>
+          <a:p>
+            <a:pPr>
+              <a:spcAft>
+                <a:spcPts val="1200"/>
+              </a:spcAft>
+            </a:pPr>
+            <a:r>
+              <a:rPr sz="2200" b="0">
+                <a:solidFill>
+                  <a:srgbClr val="1A1A1A"/>
+                </a:solidFill>
+                <a:latin typeface="Calibri"/>
+              </a:rPr>
+              <a:t>Sponsors: AWS and Anthropic.</a:t>
+            </a:r>
+          </a:p>
+          <a:p>
+            <a:pPr>
+              <a:spcAft>
+                <a:spcPts val="1200"/>
+              </a:spcAft>
+            </a:pPr>
+            <a:r>
+              <a:rPr sz="2200" b="0">
+                <a:solidFill>
+                  <a:srgbClr val="1A1A1A"/>
+                </a:solidFill>
+                <a:latin typeface="Calibri"/>
+              </a:rPr>
+              <a:t>Above all, the family.</a:t>
+            </a:r>
+          </a:p>
+        </p:txBody>
+      </p:sp>
     </p:spTree>
   </p:cSld>
   <p:clrMapOvr>
@@ -3490,8 +3651,8 @@
         </p:nvSpPr>
         <p:spPr>
           <a:xfrm>
-            <a:off x="457200" y="274320"/>
-            <a:ext cx="11247120" cy="822960"/>
+            <a:off x="502920" y="256032"/>
+            <a:ext cx="11155680" cy="640080"/>
           </a:xfrm>
           <a:prstGeom prst="rect">
             <a:avLst/>
@@ -3504,9 +3665,15 @@
           </a:bodyPr>
           <a:lstStyle/>
           <a:p>
-            <a:r>
-              <a:rPr sz="3000" b="1"/>
-              <a:t>The cause — confirmed</a:t>
+            <a:pPr algn="l"/>
+            <a:r>
+              <a:rPr sz="2800" b="1">
+                <a:solidFill>
+                  <a:srgbClr val="1E3A5F"/>
+                </a:solidFill>
+                <a:latin typeface="Calibri"/>
+              </a:rPr>
+              <a:t>The cause. Confirmed.</a:t>
             </a:r>
           </a:p>
         </p:txBody>
@@ -3527,8 +3694,8 @@
         </p:blipFill>
         <p:spPr>
           <a:xfrm>
-            <a:off x="1097280" y="1280160"/>
-            <a:ext cx="9966960" cy="3388766"/>
+            <a:off x="640080" y="1051560"/>
+            <a:ext cx="10881360" cy="4275002"/>
           </a:xfrm>
           <a:prstGeom prst="rect">
             <a:avLst/>
@@ -3543,8 +3710,8 @@
         </p:nvSpPr>
         <p:spPr>
           <a:xfrm>
-            <a:off x="1097280" y="4623206"/>
-            <a:ext cx="9966960" cy="457200"/>
+            <a:off x="640080" y="6263640"/>
+            <a:ext cx="10881360" cy="320040"/>
           </a:xfrm>
           <a:prstGeom prst="rect">
             <a:avLst/>
@@ -3558,8 +3725,13 @@
           <a:lstStyle/>
           <a:p>
             <a:r>
-              <a:rPr sz="1200" i="1"/>
-              <a:t>100.0 rank points / F-max 1.000 — full match, Track 1</a:t>
+              <a:rPr sz="1300" b="0">
+                <a:solidFill>
+                  <a:srgbClr val="4B5563"/>
+                </a:solidFill>
+                <a:latin typeface="Calibri"/>
+              </a:rPr>
+              <a:t>Track 1 score: 100.0 rank points. F-max 1.000. Full match.</a:t>
             </a:r>
           </a:p>
         </p:txBody>
@@ -3590,8 +3762,8 @@
         </p:nvSpPr>
         <p:spPr>
           <a:xfrm>
-            <a:off x="457200" y="274320"/>
-            <a:ext cx="11247120" cy="822960"/>
+            <a:off x="502920" y="256032"/>
+            <a:ext cx="11155680" cy="640080"/>
           </a:xfrm>
           <a:prstGeom prst="rect">
             <a:avLst/>
@@ -3604,9 +3776,15 @@
           </a:bodyPr>
           <a:lstStyle/>
           <a:p>
-            <a:r>
-              <a:rPr sz="3000" b="1"/>
-              <a:t>The hard truth</a:t>
+            <a:pPr algn="l"/>
+            <a:r>
+              <a:rPr sz="2800" b="1">
+                <a:solidFill>
+                  <a:srgbClr val="1E3A5F"/>
+                </a:solidFill>
+                <a:latin typeface="Calibri"/>
+              </a:rPr>
+              <a:t>The constraint</a:t>
             </a:r>
           </a:p>
         </p:txBody>
@@ -3619,8 +3797,8 @@
         </p:nvSpPr>
         <p:spPr>
           <a:xfrm>
-            <a:off x="731520" y="1463040"/>
-            <a:ext cx="10698480" cy="5029200"/>
+            <a:off x="640080" y="1645920"/>
+            <a:ext cx="10881360" cy="4754880"/>
           </a:xfrm>
           <a:prstGeom prst="rect">
             <a:avLst/>
@@ -3628,42 +3806,56 @@
           <a:noFill/>
         </p:spPr>
         <p:txBody>
-          <a:bodyPr wrap="none">
+          <a:bodyPr wrap="square">
             <a:spAutoFit/>
           </a:bodyPr>
           <a:lstStyle/>
-          <a:p/>
           <a:p>
             <a:pPr>
               <a:spcAft>
-                <a:spcPts val="1400"/>
+                <a:spcPts val="1200"/>
               </a:spcAft>
             </a:pPr>
             <a:r>
-              <a:rPr sz="2000"/>
-              <a:t>No approved drug raises BubR1.</a:t>
+              <a:rPr sz="2400" b="0">
+                <a:solidFill>
+                  <a:srgbClr val="1A1A1A"/>
+                </a:solidFill>
+                <a:latin typeface="Calibri"/>
+              </a:rPr>
+              <a:t>No approved drug increases BubR1.</a:t>
             </a:r>
           </a:p>
           <a:p>
             <a:pPr>
               <a:spcAft>
-                <a:spcPts val="1400"/>
+                <a:spcPts val="1200"/>
               </a:spcAft>
             </a:pPr>
             <a:r>
-              <a:rPr sz="2000"/>
-              <a:t>We cannot poison the checkpoint further — it is already broken.</a:t>
+              <a:rPr sz="2400" b="0">
+                <a:solidFill>
+                  <a:srgbClr val="1A1A1A"/>
+                </a:solidFill>
+                <a:latin typeface="Calibri"/>
+              </a:rPr>
+              <a:t>We must not decrease checkpoint function more. The checkpoint already does not work.</a:t>
             </a:r>
           </a:p>
           <a:p>
             <a:pPr>
               <a:spcAft>
-                <a:spcPts val="1400"/>
+                <a:spcPts val="1200"/>
               </a:spcAft>
             </a:pPr>
             <a:r>
-              <a:rPr sz="2000"/>
-              <a:t>So we map three attack surfaces: the tumor, the stress, the protein.</a:t>
+              <a:rPr sz="2400" b="0">
+                <a:solidFill>
+                  <a:srgbClr val="1A1A1A"/>
+                </a:solidFill>
+                <a:latin typeface="Calibri"/>
+              </a:rPr>
+              <a:t>We map three target groups: the tumor, the stress, and the protein.</a:t>
             </a:r>
           </a:p>
         </p:txBody>
@@ -3694,8 +3886,8 @@
         </p:nvSpPr>
         <p:spPr>
           <a:xfrm>
-            <a:off x="457200" y="274320"/>
-            <a:ext cx="11247120" cy="822960"/>
+            <a:off x="502920" y="256032"/>
+            <a:ext cx="11155680" cy="640080"/>
           </a:xfrm>
           <a:prstGeom prst="rect">
             <a:avLst/>
@@ -3708,9 +3900,15 @@
           </a:bodyPr>
           <a:lstStyle/>
           <a:p>
-            <a:r>
-              <a:rPr sz="3000" b="1"/>
-              <a:t>Mechanism: genotype to drug</a:t>
+            <a:pPr algn="l"/>
+            <a:r>
+              <a:rPr sz="2800" b="1">
+                <a:solidFill>
+                  <a:srgbClr val="1E3A5F"/>
+                </a:solidFill>
+                <a:latin typeface="Calibri"/>
+              </a:rPr>
+              <a:t>Mechanism. From genotype to drug.</a:t>
             </a:r>
           </a:p>
         </p:txBody>
@@ -3731,8 +3929,8 @@
         </p:blipFill>
         <p:spPr>
           <a:xfrm>
-            <a:off x="1097280" y="1280160"/>
-            <a:ext cx="9966960" cy="5182819"/>
+            <a:off x="1051560" y="987552"/>
+            <a:ext cx="10058400" cy="5668165"/>
           </a:xfrm>
           <a:prstGeom prst="rect">
             <a:avLst/>
@@ -3765,8 +3963,8 @@
         </p:nvSpPr>
         <p:spPr>
           <a:xfrm>
-            <a:off x="457200" y="274320"/>
-            <a:ext cx="11247120" cy="822960"/>
+            <a:off x="502920" y="256032"/>
+            <a:ext cx="11155680" cy="640080"/>
           </a:xfrm>
           <a:prstGeom prst="rect">
             <a:avLst/>
@@ -3779,66 +3977,210 @@
           </a:bodyPr>
           <a:lstStyle/>
           <a:p>
-            <a:r>
-              <a:rPr sz="3000" b="1"/>
-              <a:t>Tier A — treat what we see today</a:t>
-            </a:r>
-          </a:p>
-        </p:txBody>
-      </p:sp>
-      <p:sp>
-        <p:nvSpPr>
-          <p:cNvPr id="3" name="TextBox 2"/>
-          <p:cNvSpPr txBox="1"/>
+            <a:pPr algn="l"/>
+            <a:r>
+              <a:rPr sz="2800" b="1">
+                <a:solidFill>
+                  <a:srgbClr val="1E3A5F"/>
+                </a:solidFill>
+                <a:latin typeface="Calibri"/>
+              </a:rPr>
+              <a:t>Tier A. Treat the signs that we see today.</a:t>
+            </a:r>
+          </a:p>
+        </p:txBody>
+      </p:sp>
+      <p:sp>
+        <p:nvSpPr>
+          <p:cNvPr id="3" name="Rounded Rectangle 2"/>
+          <p:cNvSpPr/>
           <p:nvPr/>
         </p:nvSpPr>
         <p:spPr>
           <a:xfrm>
-            <a:off x="731520" y="1463040"/>
-            <a:ext cx="10698480" cy="5029200"/>
-          </a:xfrm>
-          <a:prstGeom prst="rect">
+            <a:off x="640080" y="1143000"/>
+            <a:ext cx="10881360" cy="1234440"/>
+          </a:xfrm>
+          <a:prstGeom prst="roundRect">
             <a:avLst/>
           </a:prstGeom>
-          <a:noFill/>
-        </p:spPr>
-        <p:txBody>
-          <a:bodyPr wrap="none">
-            <a:spAutoFit/>
-          </a:bodyPr>
-          <a:lstStyle/>
-          <a:p/>
-          <a:p>
-            <a:pPr>
-              <a:spcAft>
-                <a:spcPts val="1400"/>
-              </a:spcAft>
-            </a:pPr>
-            <a:r>
-              <a:rPr sz="2000"/>
-              <a:t>Adavosertib + irinotecan — pediatric trial defines the dose (NCT02095132), RMS arm</a:t>
-            </a:r>
-          </a:p>
-          <a:p>
-            <a:pPr>
-              <a:spcAft>
-                <a:spcPts val="1400"/>
-              </a:spcAft>
-            </a:pPr>
-            <a:r>
-              <a:rPr sz="2000"/>
-              <a:t>Potassium citrate + thiazide — standard, safe, bone-protective for nephrocalcinosis</a:t>
-            </a:r>
-          </a:p>
-          <a:p>
-            <a:pPr>
-              <a:spcAft>
-                <a:spcPts val="1400"/>
-              </a:spcAft>
-            </a:pPr>
-            <a:r>
-              <a:rPr sz="2000"/>
-              <a:t>Alisertib as alternate mitotic driver (COG ADVL0921)</a:t>
+          <a:solidFill>
+            <a:srgbClr val="F8FAFC"/>
+          </a:solidFill>
+          <a:ln w="19050">
+            <a:solidFill>
+              <a:srgbClr val="166534"/>
+            </a:solidFill>
+          </a:ln>
+        </p:spPr>
+        <p:style>
+          <a:lnRef idx="1">
+            <a:schemeClr val="accent1"/>
+          </a:lnRef>
+          <a:fillRef idx="3">
+            <a:schemeClr val="accent1"/>
+          </a:fillRef>
+          <a:effectRef idx="2">
+            <a:schemeClr val="accent1"/>
+          </a:effectRef>
+          <a:fontRef idx="minor">
+            <a:schemeClr val="lt1"/>
+          </a:fontRef>
+        </p:style>
+        <p:txBody>
+          <a:bodyPr rtlCol="0" anchor="ctr" wrap="square"/>
+          <a:lstStyle/>
+          <a:p>
+            <a:pPr algn="ctr"/>
+            <a:r>
+              <a:rPr sz="1800" b="1">
+                <a:solidFill>
+                  <a:srgbClr val="166534"/>
+                </a:solidFill>
+                <a:latin typeface="Calibri"/>
+              </a:rPr>
+              <a:t>Adavosertib plus irinotecan</a:t>
+            </a:r>
+          </a:p>
+          <a:p>
+            <a:r>
+              <a:rPr sz="1600" b="0">
+                <a:solidFill>
+                  <a:srgbClr val="1A1A1A"/>
+                </a:solidFill>
+                <a:latin typeface="Calibri"/>
+              </a:rPr>
+              <a:t>A pediatric trial sets the dose (NCT02095132). The trial has a rhabdomyosarcoma arm.</a:t>
+            </a:r>
+          </a:p>
+        </p:txBody>
+      </p:sp>
+      <p:sp>
+        <p:nvSpPr>
+          <p:cNvPr id="4" name="Rounded Rectangle 3"/>
+          <p:cNvSpPr/>
+          <p:nvPr/>
+        </p:nvSpPr>
+        <p:spPr>
+          <a:xfrm>
+            <a:off x="640080" y="2606040"/>
+            <a:ext cx="10881360" cy="1234440"/>
+          </a:xfrm>
+          <a:prstGeom prst="roundRect">
+            <a:avLst/>
+          </a:prstGeom>
+          <a:solidFill>
+            <a:srgbClr val="F8FAFC"/>
+          </a:solidFill>
+          <a:ln w="19050">
+            <a:solidFill>
+              <a:srgbClr val="166534"/>
+            </a:solidFill>
+          </a:ln>
+        </p:spPr>
+        <p:style>
+          <a:lnRef idx="1">
+            <a:schemeClr val="accent1"/>
+          </a:lnRef>
+          <a:fillRef idx="3">
+            <a:schemeClr val="accent1"/>
+          </a:fillRef>
+          <a:effectRef idx="2">
+            <a:schemeClr val="accent1"/>
+          </a:effectRef>
+          <a:fontRef idx="minor">
+            <a:schemeClr val="lt1"/>
+          </a:fontRef>
+        </p:style>
+        <p:txBody>
+          <a:bodyPr rtlCol="0" anchor="ctr" wrap="square"/>
+          <a:lstStyle/>
+          <a:p>
+            <a:pPr algn="ctr"/>
+            <a:r>
+              <a:rPr sz="1800" b="1">
+                <a:solidFill>
+                  <a:srgbClr val="166534"/>
+                </a:solidFill>
+                <a:latin typeface="Calibri"/>
+              </a:rPr>
+              <a:t>Potassium citrate plus a thiazide</a:t>
+            </a:r>
+          </a:p>
+          <a:p>
+            <a:r>
+              <a:rPr sz="1600" b="0">
+                <a:solidFill>
+                  <a:srgbClr val="1A1A1A"/>
+                </a:solidFill>
+                <a:latin typeface="Calibri"/>
+              </a:rPr>
+              <a:t>Standard care for nephrocalcinosis. Safe in children. Protects bone.</a:t>
+            </a:r>
+          </a:p>
+        </p:txBody>
+      </p:sp>
+      <p:sp>
+        <p:nvSpPr>
+          <p:cNvPr id="5" name="Rounded Rectangle 4"/>
+          <p:cNvSpPr/>
+          <p:nvPr/>
+        </p:nvSpPr>
+        <p:spPr>
+          <a:xfrm>
+            <a:off x="640080" y="4069080"/>
+            <a:ext cx="10881360" cy="1234440"/>
+          </a:xfrm>
+          <a:prstGeom prst="roundRect">
+            <a:avLst/>
+          </a:prstGeom>
+          <a:solidFill>
+            <a:srgbClr val="F8FAFC"/>
+          </a:solidFill>
+          <a:ln w="19050">
+            <a:solidFill>
+              <a:srgbClr val="166534"/>
+            </a:solidFill>
+          </a:ln>
+        </p:spPr>
+        <p:style>
+          <a:lnRef idx="1">
+            <a:schemeClr val="accent1"/>
+          </a:lnRef>
+          <a:fillRef idx="3">
+            <a:schemeClr val="accent1"/>
+          </a:fillRef>
+          <a:effectRef idx="2">
+            <a:schemeClr val="accent1"/>
+          </a:effectRef>
+          <a:fontRef idx="minor">
+            <a:schemeClr val="lt1"/>
+          </a:fontRef>
+        </p:style>
+        <p:txBody>
+          <a:bodyPr rtlCol="0" anchor="ctr" wrap="square"/>
+          <a:lstStyle/>
+          <a:p>
+            <a:pPr algn="ctr"/>
+            <a:r>
+              <a:rPr sz="1800" b="1">
+                <a:solidFill>
+                  <a:srgbClr val="166534"/>
+                </a:solidFill>
+                <a:latin typeface="Calibri"/>
+              </a:rPr>
+              <a:t>Alisertib</a:t>
+            </a:r>
+          </a:p>
+          <a:p>
+            <a:r>
+              <a:rPr sz="1600" b="0">
+                <a:solidFill>
+                  <a:srgbClr val="1A1A1A"/>
+                </a:solidFill>
+                <a:latin typeface="Calibri"/>
+              </a:rPr>
+              <a:t>Alternate mitotic drug. COG phase 2 trial ADVL0921.</a:t>
             </a:r>
           </a:p>
         </p:txBody>
@@ -3869,8 +4211,8 @@
         </p:nvSpPr>
         <p:spPr>
           <a:xfrm>
-            <a:off x="457200" y="274320"/>
-            <a:ext cx="11247120" cy="822960"/>
+            <a:off x="502920" y="256032"/>
+            <a:ext cx="11155680" cy="640080"/>
           </a:xfrm>
           <a:prstGeom prst="rect">
             <a:avLst/>
@@ -3883,66 +4225,210 @@
           </a:bodyPr>
           <a:lstStyle/>
           <a:p>
-            <a:r>
-              <a:rPr sz="3000" b="1"/>
-              <a:t>Tier B — buffer the stress</a:t>
-            </a:r>
-          </a:p>
-        </p:txBody>
-      </p:sp>
-      <p:sp>
-        <p:nvSpPr>
-          <p:cNvPr id="3" name="TextBox 2"/>
-          <p:cNvSpPr txBox="1"/>
+            <a:pPr algn="l"/>
+            <a:r>
+              <a:rPr sz="2800" b="1">
+                <a:solidFill>
+                  <a:srgbClr val="1E3A5F"/>
+                </a:solidFill>
+                <a:latin typeface="Calibri"/>
+              </a:rPr>
+              <a:t>Tier B. Decrease the stress.</a:t>
+            </a:r>
+          </a:p>
+        </p:txBody>
+      </p:sp>
+      <p:sp>
+        <p:nvSpPr>
+          <p:cNvPr id="3" name="Rounded Rectangle 2"/>
+          <p:cNvSpPr/>
           <p:nvPr/>
         </p:nvSpPr>
         <p:spPr>
           <a:xfrm>
-            <a:off x="731520" y="1463040"/>
-            <a:ext cx="10698480" cy="5029200"/>
-          </a:xfrm>
-          <a:prstGeom prst="rect">
+            <a:off x="640080" y="1143000"/>
+            <a:ext cx="10881360" cy="1234440"/>
+          </a:xfrm>
+          <a:prstGeom prst="roundRect">
             <a:avLst/>
           </a:prstGeom>
-          <a:noFill/>
-        </p:spPr>
-        <p:txBody>
-          <a:bodyPr wrap="none">
-            <a:spAutoFit/>
-          </a:bodyPr>
-          <a:lstStyle/>
-          <a:p/>
-          <a:p>
-            <a:pPr>
-              <a:spcAft>
-                <a:spcPts val="1400"/>
-              </a:spcAft>
-            </a:pPr>
-            <a:r>
-              <a:rPr sz="2000"/>
-              <a:t>Aneuploid cells turn on mTOR and pour out inflammatory signals</a:t>
-            </a:r>
-          </a:p>
-          <a:p>
-            <a:pPr>
-              <a:spcAft>
-                <a:spcPts val="1400"/>
-              </a:spcAft>
-            </a:pPr>
-            <a:r>
-              <a:rPr sz="2000"/>
-              <a:t>Everolimus quiets that axis — deepest pediatric safety record (EXIST-1, transplant)</a:t>
-            </a:r>
-          </a:p>
-          <a:p>
-            <a:pPr>
-              <a:spcAft>
-                <a:spcPts val="1400"/>
-              </a:spcAft>
-            </a:pPr>
-            <a:r>
-              <a:rPr sz="2000"/>
-              <a:t>Honest claim: lowers the fire, does not fix the checkpoint</a:t>
+          <a:solidFill>
+            <a:srgbClr val="F8FAFC"/>
+          </a:solidFill>
+          <a:ln w="19050">
+            <a:solidFill>
+              <a:srgbClr val="1D4E89"/>
+            </a:solidFill>
+          </a:ln>
+        </p:spPr>
+        <p:style>
+          <a:lnRef idx="1">
+            <a:schemeClr val="accent1"/>
+          </a:lnRef>
+          <a:fillRef idx="3">
+            <a:schemeClr val="accent1"/>
+          </a:fillRef>
+          <a:effectRef idx="2">
+            <a:schemeClr val="accent1"/>
+          </a:effectRef>
+          <a:fontRef idx="minor">
+            <a:schemeClr val="lt1"/>
+          </a:fontRef>
+        </p:style>
+        <p:txBody>
+          <a:bodyPr rtlCol="0" anchor="ctr" wrap="square"/>
+          <a:lstStyle/>
+          <a:p>
+            <a:pPr algn="ctr"/>
+            <a:r>
+              <a:rPr sz="1800" b="1">
+                <a:solidFill>
+                  <a:srgbClr val="1D4E89"/>
+                </a:solidFill>
+                <a:latin typeface="Calibri"/>
+              </a:rPr>
+              <a:t>Aneuploid cells increase mTOR.</a:t>
+            </a:r>
+          </a:p>
+          <a:p>
+            <a:r>
+              <a:rPr sz="1600" b="0">
+                <a:solidFill>
+                  <a:srgbClr val="1A1A1A"/>
+                </a:solidFill>
+                <a:latin typeface="Calibri"/>
+              </a:rPr>
+              <a:t>These cells release inflammatory signals.</a:t>
+            </a:r>
+          </a:p>
+        </p:txBody>
+      </p:sp>
+      <p:sp>
+        <p:nvSpPr>
+          <p:cNvPr id="4" name="Rounded Rectangle 3"/>
+          <p:cNvSpPr/>
+          <p:nvPr/>
+        </p:nvSpPr>
+        <p:spPr>
+          <a:xfrm>
+            <a:off x="640080" y="2606040"/>
+            <a:ext cx="10881360" cy="1234440"/>
+          </a:xfrm>
+          <a:prstGeom prst="roundRect">
+            <a:avLst/>
+          </a:prstGeom>
+          <a:solidFill>
+            <a:srgbClr val="F8FAFC"/>
+          </a:solidFill>
+          <a:ln w="19050">
+            <a:solidFill>
+              <a:srgbClr val="1D4E89"/>
+            </a:solidFill>
+          </a:ln>
+        </p:spPr>
+        <p:style>
+          <a:lnRef idx="1">
+            <a:schemeClr val="accent1"/>
+          </a:lnRef>
+          <a:fillRef idx="3">
+            <a:schemeClr val="accent1"/>
+          </a:fillRef>
+          <a:effectRef idx="2">
+            <a:schemeClr val="accent1"/>
+          </a:effectRef>
+          <a:fontRef idx="minor">
+            <a:schemeClr val="lt1"/>
+          </a:fontRef>
+        </p:style>
+        <p:txBody>
+          <a:bodyPr rtlCol="0" anchor="ctr" wrap="square"/>
+          <a:lstStyle/>
+          <a:p>
+            <a:pPr algn="ctr"/>
+            <a:r>
+              <a:rPr sz="1800" b="1">
+                <a:solidFill>
+                  <a:srgbClr val="1D4E89"/>
+                </a:solidFill>
+                <a:latin typeface="Calibri"/>
+              </a:rPr>
+              <a:t>Everolimus decreases that signal.</a:t>
+            </a:r>
+          </a:p>
+          <a:p>
+            <a:r>
+              <a:rPr sz="1600" b="0">
+                <a:solidFill>
+                  <a:srgbClr val="1A1A1A"/>
+                </a:solidFill>
+                <a:latin typeface="Calibri"/>
+              </a:rPr>
+              <a:t>Pediatric safety data are large. EXIST-1. Transplant infants.</a:t>
+            </a:r>
+          </a:p>
+        </p:txBody>
+      </p:sp>
+      <p:sp>
+        <p:nvSpPr>
+          <p:cNvPr id="5" name="Rounded Rectangle 4"/>
+          <p:cNvSpPr/>
+          <p:nvPr/>
+        </p:nvSpPr>
+        <p:spPr>
+          <a:xfrm>
+            <a:off x="640080" y="4069080"/>
+            <a:ext cx="10881360" cy="1234440"/>
+          </a:xfrm>
+          <a:prstGeom prst="roundRect">
+            <a:avLst/>
+          </a:prstGeom>
+          <a:solidFill>
+            <a:srgbClr val="F8FAFC"/>
+          </a:solidFill>
+          <a:ln w="19050">
+            <a:solidFill>
+              <a:srgbClr val="1D4E89"/>
+            </a:solidFill>
+          </a:ln>
+        </p:spPr>
+        <p:style>
+          <a:lnRef idx="1">
+            <a:schemeClr val="accent1"/>
+          </a:lnRef>
+          <a:fillRef idx="3">
+            <a:schemeClr val="accent1"/>
+          </a:fillRef>
+          <a:effectRef idx="2">
+            <a:schemeClr val="accent1"/>
+          </a:effectRef>
+          <a:fontRef idx="minor">
+            <a:schemeClr val="lt1"/>
+          </a:fontRef>
+        </p:style>
+        <p:txBody>
+          <a:bodyPr rtlCol="0" anchor="ctr" wrap="square"/>
+          <a:lstStyle/>
+          <a:p>
+            <a:pPr algn="ctr"/>
+            <a:r>
+              <a:rPr sz="1800" b="1">
+                <a:solidFill>
+                  <a:srgbClr val="1D4E89"/>
+                </a:solidFill>
+                <a:latin typeface="Calibri"/>
+              </a:rPr>
+              <a:t>Honest claim</a:t>
+            </a:r>
+          </a:p>
+          <a:p>
+            <a:r>
+              <a:rPr sz="1600" b="0">
+                <a:solidFill>
+                  <a:srgbClr val="1A1A1A"/>
+                </a:solidFill>
+                <a:latin typeface="Calibri"/>
+              </a:rPr>
+              <a:t>This drug decreases damage. This drug does not repair the checkpoint.</a:t>
             </a:r>
           </a:p>
         </p:txBody>
@@ -3973,8 +4459,8 @@
         </p:nvSpPr>
         <p:spPr>
           <a:xfrm>
-            <a:off x="457200" y="274320"/>
-            <a:ext cx="11247120" cy="822960"/>
+            <a:off x="502920" y="256032"/>
+            <a:ext cx="11155680" cy="640080"/>
           </a:xfrm>
           <a:prstGeom prst="rect">
             <a:avLst/>
@@ -3987,66 +4473,210 @@
           </a:bodyPr>
           <a:lstStyle/>
           <a:p>
-            <a:r>
-              <a:rPr sz="3000" b="1"/>
-              <a:t>Tier C — restore the protein (innovation)</a:t>
-            </a:r>
-          </a:p>
-        </p:txBody>
-      </p:sp>
-      <p:sp>
-        <p:nvSpPr>
-          <p:cNvPr id="3" name="TextBox 2"/>
-          <p:cNvSpPr txBox="1"/>
+            <a:pPr algn="l"/>
+            <a:r>
+              <a:rPr sz="2800" b="1">
+                <a:solidFill>
+                  <a:srgbClr val="1E3A5F"/>
+                </a:solidFill>
+                <a:latin typeface="Calibri"/>
+              </a:rPr>
+              <a:t>Tier C. Restore the protein.</a:t>
+            </a:r>
+          </a:p>
+        </p:txBody>
+      </p:sp>
+      <p:sp>
+        <p:nvSpPr>
+          <p:cNvPr id="3" name="Rounded Rectangle 2"/>
+          <p:cNvSpPr/>
           <p:nvPr/>
         </p:nvSpPr>
         <p:spPr>
           <a:xfrm>
-            <a:off x="731520" y="1463040"/>
-            <a:ext cx="10698480" cy="5029200"/>
-          </a:xfrm>
-          <a:prstGeom prst="rect">
+            <a:off x="640080" y="1143000"/>
+            <a:ext cx="10881360" cy="1234440"/>
+          </a:xfrm>
+          <a:prstGeom prst="roundRect">
             <a:avLst/>
           </a:prstGeom>
-          <a:noFill/>
-        </p:spPr>
-        <p:txBody>
-          <a:bodyPr wrap="none">
-            <a:spAutoFit/>
-          </a:bodyPr>
-          <a:lstStyle/>
-          <a:p/>
-          <a:p>
-            <a:pPr>
-              <a:spcAft>
-                <a:spcPts val="1400"/>
-              </a:spcAft>
-            </a:pPr>
-            <a:r>
-              <a:rPr sz="2000"/>
-              <a:t>In mice, BubR1 overexpression repairs the checkpoint and extends lifespan (Baker 2013)</a:t>
-            </a:r>
-          </a:p>
-          <a:p>
-            <a:pPr>
-              <a:spcAft>
-                <a:spcPts val="1400"/>
-              </a:spcAft>
-            </a:pPr>
-            <a:r>
-              <a:rPr sz="2000"/>
-              <a:t>This child still makes weakened BubR1 from his missense allele</a:t>
-            </a:r>
-          </a:p>
-          <a:p>
-            <a:pPr>
-              <a:spcAft>
-                <a:spcPts val="1400"/>
-              </a:spcAft>
-            </a:pPr>
-            <a:r>
-              <a:rPr sz="2000"/>
-              <a:t>Three routes: AAV augmentation · SIRT2-axis stabilization · peptide rescue</a:t>
+          <a:solidFill>
+            <a:srgbClr val="F8FAFC"/>
+          </a:solidFill>
+          <a:ln w="19050">
+            <a:solidFill>
+              <a:srgbClr val="9A3412"/>
+            </a:solidFill>
+          </a:ln>
+        </p:spPr>
+        <p:style>
+          <a:lnRef idx="1">
+            <a:schemeClr val="accent1"/>
+          </a:lnRef>
+          <a:fillRef idx="3">
+            <a:schemeClr val="accent1"/>
+          </a:fillRef>
+          <a:effectRef idx="2">
+            <a:schemeClr val="accent1"/>
+          </a:effectRef>
+          <a:fontRef idx="minor">
+            <a:schemeClr val="lt1"/>
+          </a:fontRef>
+        </p:style>
+        <p:txBody>
+          <a:bodyPr rtlCol="0" anchor="ctr" wrap="square"/>
+          <a:lstStyle/>
+          <a:p>
+            <a:pPr algn="ctr"/>
+            <a:r>
+              <a:rPr sz="1800" b="1">
+                <a:solidFill>
+                  <a:srgbClr val="9A3412"/>
+                </a:solidFill>
+                <a:latin typeface="Calibri"/>
+              </a:rPr>
+              <a:t>Mouse data (Baker 2013)</a:t>
+            </a:r>
+          </a:p>
+          <a:p>
+            <a:r>
+              <a:rPr sz="1600" b="0">
+                <a:solidFill>
+                  <a:srgbClr val="1A1A1A"/>
+                </a:solidFill>
+                <a:latin typeface="Calibri"/>
+              </a:rPr>
+              <a:t>More BubR1 repairs the checkpoint. More BubR1 extends lifespan.</a:t>
+            </a:r>
+          </a:p>
+        </p:txBody>
+      </p:sp>
+      <p:sp>
+        <p:nvSpPr>
+          <p:cNvPr id="4" name="Rounded Rectangle 3"/>
+          <p:cNvSpPr/>
+          <p:nvPr/>
+        </p:nvSpPr>
+        <p:spPr>
+          <a:xfrm>
+            <a:off x="640080" y="2606040"/>
+            <a:ext cx="10881360" cy="1234440"/>
+          </a:xfrm>
+          <a:prstGeom prst="roundRect">
+            <a:avLst/>
+          </a:prstGeom>
+          <a:solidFill>
+            <a:srgbClr val="F8FAFC"/>
+          </a:solidFill>
+          <a:ln w="19050">
+            <a:solidFill>
+              <a:srgbClr val="9A3412"/>
+            </a:solidFill>
+          </a:ln>
+        </p:spPr>
+        <p:style>
+          <a:lnRef idx="1">
+            <a:schemeClr val="accent1"/>
+          </a:lnRef>
+          <a:fillRef idx="3">
+            <a:schemeClr val="accent1"/>
+          </a:fillRef>
+          <a:effectRef idx="2">
+            <a:schemeClr val="accent1"/>
+          </a:effectRef>
+          <a:fontRef idx="minor">
+            <a:schemeClr val="lt1"/>
+          </a:fontRef>
+        </p:style>
+        <p:txBody>
+          <a:bodyPr rtlCol="0" anchor="ctr" wrap="square"/>
+          <a:lstStyle/>
+          <a:p>
+            <a:pPr algn="ctr"/>
+            <a:r>
+              <a:rPr sz="1800" b="1">
+                <a:solidFill>
+                  <a:srgbClr val="9A3412"/>
+                </a:solidFill>
+                <a:latin typeface="Calibri"/>
+              </a:rPr>
+              <a:t>This child still makes weakened BubR1 from the missense allele.</a:t>
+            </a:r>
+          </a:p>
+          <a:p>
+            <a:r>
+              <a:rPr sz="1600" b="0">
+                <a:solidFill>
+                  <a:srgbClr val="1A1A1A"/>
+                </a:solidFill>
+                <a:latin typeface="Calibri"/>
+              </a:rPr>
+              <a:t>A small increase in BubR1 level can restore checkpoint function.</a:t>
+            </a:r>
+          </a:p>
+        </p:txBody>
+      </p:sp>
+      <p:sp>
+        <p:nvSpPr>
+          <p:cNvPr id="5" name="Rounded Rectangle 4"/>
+          <p:cNvSpPr/>
+          <p:nvPr/>
+        </p:nvSpPr>
+        <p:spPr>
+          <a:xfrm>
+            <a:off x="640080" y="4069080"/>
+            <a:ext cx="10881360" cy="1234440"/>
+          </a:xfrm>
+          <a:prstGeom prst="roundRect">
+            <a:avLst/>
+          </a:prstGeom>
+          <a:solidFill>
+            <a:srgbClr val="F8FAFC"/>
+          </a:solidFill>
+          <a:ln w="19050">
+            <a:solidFill>
+              <a:srgbClr val="9A3412"/>
+            </a:solidFill>
+          </a:ln>
+        </p:spPr>
+        <p:style>
+          <a:lnRef idx="1">
+            <a:schemeClr val="accent1"/>
+          </a:lnRef>
+          <a:fillRef idx="3">
+            <a:schemeClr val="accent1"/>
+          </a:fillRef>
+          <a:effectRef idx="2">
+            <a:schemeClr val="accent1"/>
+          </a:effectRef>
+          <a:fontRef idx="minor">
+            <a:schemeClr val="lt1"/>
+          </a:fontRef>
+        </p:style>
+        <p:txBody>
+          <a:bodyPr rtlCol="0" anchor="ctr" wrap="square"/>
+          <a:lstStyle/>
+          <a:p>
+            <a:pPr algn="ctr"/>
+            <a:r>
+              <a:rPr sz="1800" b="1">
+                <a:solidFill>
+                  <a:srgbClr val="9A3412"/>
+                </a:solidFill>
+                <a:latin typeface="Calibri"/>
+              </a:rPr>
+              <a:t>Three routes. One goal.</a:t>
+            </a:r>
+          </a:p>
+          <a:p>
+            <a:r>
+              <a:rPr sz="1600" b="0">
+                <a:solidFill>
+                  <a:srgbClr val="1A1A1A"/>
+                </a:solidFill>
+                <a:latin typeface="Calibri"/>
+              </a:rPr>
+              <a:t>AAV gene augmentation. SIRT2-axis stabilization. Peptide rescue.</a:t>
             </a:r>
           </a:p>
         </p:txBody>
@@ -4077,8 +4707,8 @@
         </p:nvSpPr>
         <p:spPr>
           <a:xfrm>
-            <a:off x="457200" y="274320"/>
-            <a:ext cx="11247120" cy="822960"/>
+            <a:off x="502920" y="256032"/>
+            <a:ext cx="11155680" cy="640080"/>
           </a:xfrm>
           <a:prstGeom prst="rect">
             <a:avLst/>
@@ -4091,16 +4721,22 @@
           </a:bodyPr>
           <a:lstStyle/>
           <a:p>
-            <a:r>
-              <a:rPr sz="3000" b="1"/>
-              <a:t>Rigor: three independent methods agree</a:t>
+            <a:pPr algn="l"/>
+            <a:r>
+              <a:rPr sz="2800" b="1">
+                <a:solidFill>
+                  <a:srgbClr val="1E3A5F"/>
+                </a:solidFill>
+                <a:latin typeface="Calibri"/>
+              </a:rPr>
+              <a:t>Both alleles change the kinase domain. The scaffold stays.</a:t>
             </a:r>
           </a:p>
         </p:txBody>
       </p:sp>
       <p:pic>
         <p:nvPicPr>
-          <p:cNvPr id="3" name="Picture 2" descr="fig_exomiser.png"/>
+          <p:cNvPr id="3" name="Picture 2" descr="fig_domainmap.png"/>
           <p:cNvPicPr>
             <a:picLocks noChangeAspect="1"/>
           </p:cNvPicPr>
@@ -4114,43 +4750,14 @@
         </p:blipFill>
         <p:spPr>
           <a:xfrm>
-            <a:off x="1097280" y="1280160"/>
-            <a:ext cx="9966960" cy="4983480"/>
+            <a:off x="411480" y="914400"/>
+            <a:ext cx="11338560" cy="5703833"/>
           </a:xfrm>
           <a:prstGeom prst="rect">
             <a:avLst/>
           </a:prstGeom>
         </p:spPr>
       </p:pic>
-      <p:sp>
-        <p:nvSpPr>
-          <p:cNvPr id="4" name="TextBox 3"/>
-          <p:cNvSpPr txBox="1"/>
-          <p:nvPr/>
-        </p:nvSpPr>
-        <p:spPr>
-          <a:xfrm>
-            <a:off x="1097280" y="6217920"/>
-            <a:ext cx="9966960" cy="457200"/>
-          </a:xfrm>
-          <a:prstGeom prst="rect">
-            <a:avLst/>
-          </a:prstGeom>
-          <a:noFill/>
-        </p:spPr>
-        <p:txBody>
-          <a:bodyPr wrap="none">
-            <a:spAutoFit/>
-          </a:bodyPr>
-          <a:lstStyle/>
-          <a:p>
-            <a:r>
-              <a:rPr sz="1200" i="1"/>
-              <a:t>Panel scan · Exomiser genome-wide (94 s, no panel) · clinical databases — all point to BUB1B</a:t>
-            </a:r>
-          </a:p>
-        </p:txBody>
-      </p:sp>
     </p:spTree>
   </p:cSld>
   <p:clrMapOvr>
@@ -4177,8 +4784,8 @@
         </p:nvSpPr>
         <p:spPr>
           <a:xfrm>
-            <a:off x="457200" y="274320"/>
-            <a:ext cx="11247120" cy="822960"/>
+            <a:off x="502920" y="256032"/>
+            <a:ext cx="11155680" cy="640080"/>
           </a:xfrm>
           <a:prstGeom prst="rect">
             <a:avLst/>
@@ -4191,23 +4798,53 @@
           </a:bodyPr>
           <a:lstStyle/>
           <a:p>
-            <a:r>
-              <a:rPr sz="3000" b="1"/>
-              <a:t>Scalability — a laptop runs it</a:t>
-            </a:r>
-          </a:p>
-        </p:txBody>
-      </p:sp>
-      <p:sp>
-        <p:nvSpPr>
-          <p:cNvPr id="3" name="TextBox 2"/>
+            <a:pPr algn="l"/>
+            <a:r>
+              <a:rPr sz="2800" b="1">
+                <a:solidFill>
+                  <a:srgbClr val="1E3A5F"/>
+                </a:solidFill>
+                <a:latin typeface="Calibri"/>
+              </a:rPr>
+              <a:t>Rigor. Three independent methods agree.</a:t>
+            </a:r>
+          </a:p>
+        </p:txBody>
+      </p:sp>
+      <p:pic>
+        <p:nvPicPr>
+          <p:cNvPr id="3" name="Picture 2" descr="fig_exomiser.png"/>
+          <p:cNvPicPr>
+            <a:picLocks noChangeAspect="1"/>
+          </p:cNvPicPr>
+          <p:nvPr/>
+        </p:nvPicPr>
+        <p:blipFill>
+          <a:blip r:embed="rId2"/>
+          <a:stretch>
+            <a:fillRect/>
+          </a:stretch>
+        </p:blipFill>
+        <p:spPr>
+          <a:xfrm>
+            <a:off x="640080" y="960120"/>
+            <a:ext cx="10881360" cy="5445233"/>
+          </a:xfrm>
+          <a:prstGeom prst="rect">
+            <a:avLst/>
+          </a:prstGeom>
+        </p:spPr>
+      </p:pic>
+      <p:sp>
+        <p:nvSpPr>
+          <p:cNvPr id="4" name="TextBox 3"/>
           <p:cNvSpPr txBox="1"/>
           <p:nvPr/>
         </p:nvSpPr>
         <p:spPr>
           <a:xfrm>
-            <a:off x="731520" y="1463040"/>
-            <a:ext cx="10698480" cy="5029200"/>
+            <a:off x="640080" y="6263640"/>
+            <a:ext cx="10881360" cy="320040"/>
           </a:xfrm>
           <a:prstGeom prst="rect">
             <a:avLst/>
@@ -4219,49 +4856,15 @@
             <a:spAutoFit/>
           </a:bodyPr>
           <a:lstStyle/>
-          <a:p/>
-          <a:p>
-            <a:pPr>
-              <a:spcAft>
-                <a:spcPts val="1400"/>
-              </a:spcAft>
-            </a:pPr>
-            <a:r>
-              <a:rPr sz="2000"/>
-              <a:t>Open Targets · DGIdb · ChEMBL · everycure/matrix-scores (39.5M pairs) — all public APIs</a:t>
-            </a:r>
-          </a:p>
-          <a:p>
-            <a:pPr>
-              <a:spcAft>
-                <a:spcPts val="1400"/>
-              </a:spcAft>
-            </a:pPr>
-            <a:r>
-              <a:rPr sz="2000"/>
-              <a:t>Full pipeline: ~6 h + $1 of electricity; genome-wide check: 94 s</a:t>
-            </a:r>
-          </a:p>
-          <a:p>
-            <a:pPr>
-              <a:spcAft>
-                <a:spcPts val="1400"/>
-              </a:spcAft>
-            </a:pPr>
-            <a:r>
-              <a:rPr sz="2000"/>
-              <a:t>Generalizes to any recessive chromosomal-instability disorder</a:t>
-            </a:r>
-          </a:p>
-          <a:p>
-            <a:pPr>
-              <a:spcAft>
-                <a:spcPts val="1400"/>
-              </a:spcAft>
-            </a:pPr>
-            <a:r>
-              <a:rPr sz="2000"/>
-              <a:t>Code and evidence: github.com/bigbag/mva-hackathon-2026</a:t>
+          <a:p>
+            <a:r>
+              <a:rPr sz="1300" b="0">
+                <a:solidFill>
+                  <a:srgbClr val="4B5563"/>
+                </a:solidFill>
+                <a:latin typeface="Calibri"/>
+              </a:rPr>
+              <a:t>Panel scan. Exomiser on the full genome (94 s, no panel). Clinical databases. All point to BUB1B.</a:t>
             </a:r>
           </a:p>
         </p:txBody>

</xml_diff>

<commit_message>
Add MLA Works Cited with verified DOIs and official hackathon links
Correct Mossé initials, Zhang author, Rio Frio, SpliceAI (Jaganathan),
gnomAD v4 (Chen Nature), and EXIST-1 57.7% from the 2016 long-term paper.
</commit_message>
<xml_diff>
--- a/track2/slides/pitch_deck.pptx
+++ b/track2/slides/pitch_deck.pptx
@@ -17,6 +17,8 @@
     <p:sldId id="265" r:id="rId16"/>
     <p:sldId id="266" r:id="rId17"/>
     <p:sldId id="267" r:id="rId18"/>
+    <p:sldId id="268" r:id="rId19"/>
+    <p:sldId id="269" r:id="rId20"/>
   </p:sldIdLst>
   <p:sldSz cx="12191695" cy="6858000" type="screen4x3"/>
   <p:notesSz cx="6858000" cy="9144000"/>
@@ -3533,7 +3535,7 @@
                 </a:solidFill>
                 <a:latin typeface="Calibri"/>
               </a:rPr>
-              <a:t>Thank you</a:t>
+              <a:t>Works Cited (MLA)</a:t>
             </a:r>
           </a:p>
         </p:txBody>
@@ -3546,7 +3548,431 @@
         </p:nvSpPr>
         <p:spPr>
           <a:xfrm>
-            <a:off x="640080" y="1645920"/>
+            <a:off x="502920" y="960120"/>
+            <a:ext cx="11155680" cy="5669280"/>
+          </a:xfrm>
+          <a:prstGeom prst="rect">
+            <a:avLst/>
+          </a:prstGeom>
+          <a:noFill/>
+        </p:spPr>
+        <p:txBody>
+          <a:bodyPr wrap="square">
+            <a:spAutoFit/>
+          </a:bodyPr>
+          <a:lstStyle/>
+          <a:p>
+            <a:pPr>
+              <a:spcAft>
+                <a:spcPts val="400"/>
+              </a:spcAft>
+            </a:pPr>
+            <a:r>
+              <a:rPr sz="1300" b="0">
+                <a:solidFill>
+                  <a:srgbClr val="1A1A1A"/>
+                </a:solidFill>
+                <a:latin typeface="Calibri"/>
+              </a:rPr>
+              <a:t>Baker, Darren J., et al. Nature Cell Biology, vol. 15, no. 1, 2013, pp. 96-102. https://doi.org/10.1038/ncb2643</a:t>
+            </a:r>
+          </a:p>
+          <a:p>
+            <a:pPr>
+              <a:spcAft>
+                <a:spcPts val="400"/>
+              </a:spcAft>
+            </a:pPr>
+            <a:r>
+              <a:rPr sz="1300" b="0">
+                <a:solidFill>
+                  <a:srgbClr val="1A1A1A"/>
+                </a:solidFill>
+                <a:latin typeface="Calibri"/>
+              </a:rPr>
+              <a:t>Franz, David Neal, et al. The Lancet, vol. 381, no. 9861, 2013, pp. 125-32. https://doi.org/10.1016/S0140-6736(12)61134-9</a:t>
+            </a:r>
+          </a:p>
+          <a:p>
+            <a:pPr>
+              <a:spcAft>
+                <a:spcPts val="400"/>
+              </a:spcAft>
+            </a:pPr>
+            <a:r>
+              <a:rPr sz="1300" b="0">
+                <a:solidFill>
+                  <a:srgbClr val="1A1A1A"/>
+                </a:solidFill>
+                <a:latin typeface="Calibri"/>
+              </a:rPr>
+              <a:t>Franz, David Neal, et al. PLOS ONE, vol. 11, no. 6, 2016, e0158476. https://doi.org/10.1371/journal.pone.0158476</a:t>
+            </a:r>
+          </a:p>
+          <a:p>
+            <a:pPr>
+              <a:spcAft>
+                <a:spcPts val="400"/>
+              </a:spcAft>
+            </a:pPr>
+            <a:r>
+              <a:rPr sz="1300" b="0">
+                <a:solidFill>
+                  <a:srgbClr val="1A1A1A"/>
+                </a:solidFill>
+                <a:latin typeface="Calibri"/>
+              </a:rPr>
+              <a:t>Hanks, Sandra, et al. Nature Genetics, vol. 36, no. 11, 2004, pp. 1159-61. https://doi.org/10.1038/ng1449</a:t>
+            </a:r>
+          </a:p>
+          <a:p>
+            <a:pPr>
+              <a:spcAft>
+                <a:spcPts val="400"/>
+              </a:spcAft>
+            </a:pPr>
+            <a:r>
+              <a:rPr sz="1300" b="0">
+                <a:solidFill>
+                  <a:srgbClr val="1A1A1A"/>
+                </a:solidFill>
+                <a:latin typeface="Calibri"/>
+              </a:rPr>
+              <a:t>Malumbres, Marcos, and Carolina Villarroya-Beltri. Nature Reviews Genetics, vol. 25, 2024, pp. 864-78. https://doi.org/10.1038/s41576-024-00762-6</a:t>
+            </a:r>
+          </a:p>
+          <a:p>
+            <a:pPr>
+              <a:spcAft>
+                <a:spcPts val="400"/>
+              </a:spcAft>
+            </a:pPr>
+            <a:r>
+              <a:rPr sz="1300" b="0">
+                <a:solidFill>
+                  <a:srgbClr val="1A1A1A"/>
+                </a:solidFill>
+                <a:latin typeface="Calibri"/>
+              </a:rPr>
+              <a:t>Mossé, Yaël P., et al. Clinical Cancer Research, vol. 25, no. 11, 2019, pp. 3229-38. https://doi.org/10.1158/1078-0432.CCR-18-2675</a:t>
+            </a:r>
+          </a:p>
+          <a:p>
+            <a:pPr>
+              <a:spcAft>
+                <a:spcPts val="400"/>
+              </a:spcAft>
+            </a:pPr>
+            <a:r>
+              <a:rPr sz="1300" b="0">
+                <a:solidFill>
+                  <a:srgbClr val="1A1A1A"/>
+                </a:solidFill>
+                <a:latin typeface="Calibri"/>
+              </a:rPr>
+              <a:t>National Cancer Institute. NCT02095132. https://clinicaltrials.gov/study/NCT02095132</a:t>
+            </a:r>
+          </a:p>
+          <a:p>
+            <a:pPr>
+              <a:spcAft>
+                <a:spcPts val="400"/>
+              </a:spcAft>
+            </a:pPr>
+            <a:r>
+              <a:rPr sz="1300" b="0">
+                <a:solidFill>
+                  <a:srgbClr val="1A1A1A"/>
+                </a:solidFill>
+                <a:latin typeface="Calibri"/>
+              </a:rPr>
+              <a:t>Sage Bionetworks. Rare Disease, Real Kid: MVA Hackathon 2026. https://sagebio-rare-disease-real-kid-mva-hackathon-2026.hf.space/</a:t>
+            </a:r>
+          </a:p>
+          <a:p>
+            <a:pPr>
+              <a:spcAft>
+                <a:spcPts val="400"/>
+              </a:spcAft>
+            </a:pPr>
+            <a:r>
+              <a:rPr sz="1300" b="0">
+                <a:solidFill>
+                  <a:srgbClr val="1A1A1A"/>
+                </a:solidFill>
+                <a:latin typeface="Calibri"/>
+              </a:rPr>
+              <a:t>Sage Bionetworks. mva-hackathon-2026-data. https://huggingface.co/datasets/SageBio/mva-hackathon-2026-data</a:t>
+            </a:r>
+          </a:p>
+        </p:txBody>
+      </p:sp>
+    </p:spTree>
+  </p:cSld>
+  <p:clrMapOvr>
+    <a:masterClrMapping/>
+  </p:clrMapOvr>
+</p:sld>
+</file>
+
+<file path=ppt/slides/slide13.xml><?xml version="1.0" encoding="utf-8"?>
+<p:sld xmlns:a="http://schemas.openxmlformats.org/drawingml/2006/main" xmlns:p="http://schemas.openxmlformats.org/presentationml/2006/main" xmlns:r="http://schemas.openxmlformats.org/officeDocument/2006/relationships">
+  <p:cSld>
+    <p:spTree>
+      <p:nvGrpSpPr>
+        <p:cNvPr id="1" name=""/>
+        <p:cNvGrpSpPr/>
+        <p:nvPr/>
+      </p:nvGrpSpPr>
+      <p:grpSpPr/>
+      <p:sp>
+        <p:nvSpPr>
+          <p:cNvPr id="2" name="TextBox 1"/>
+          <p:cNvSpPr txBox="1"/>
+          <p:nvPr/>
+        </p:nvSpPr>
+        <p:spPr>
+          <a:xfrm>
+            <a:off x="502920" y="256032"/>
+            <a:ext cx="11155680" cy="640080"/>
+          </a:xfrm>
+          <a:prstGeom prst="rect">
+            <a:avLst/>
+          </a:prstGeom>
+          <a:noFill/>
+        </p:spPr>
+        <p:txBody>
+          <a:bodyPr wrap="none">
+            <a:spAutoFit/>
+          </a:bodyPr>
+          <a:lstStyle/>
+          <a:p>
+            <a:pPr algn="l"/>
+            <a:r>
+              <a:rPr sz="2800" b="1">
+                <a:solidFill>
+                  <a:srgbClr val="1E3A5F"/>
+                </a:solidFill>
+                <a:latin typeface="Calibri"/>
+              </a:rPr>
+              <a:t>Works Cited (MLA), continued</a:t>
+            </a:r>
+          </a:p>
+        </p:txBody>
+      </p:sp>
+      <p:sp>
+        <p:nvSpPr>
+          <p:cNvPr id="3" name="TextBox 2"/>
+          <p:cNvSpPr txBox="1"/>
+          <p:nvPr/>
+        </p:nvSpPr>
+        <p:spPr>
+          <a:xfrm>
+            <a:off x="502920" y="960120"/>
+            <a:ext cx="11155680" cy="5669280"/>
+          </a:xfrm>
+          <a:prstGeom prst="rect">
+            <a:avLst/>
+          </a:prstGeom>
+          <a:noFill/>
+        </p:spPr>
+        <p:txBody>
+          <a:bodyPr wrap="square">
+            <a:spAutoFit/>
+          </a:bodyPr>
+          <a:lstStyle/>
+          <a:p>
+            <a:pPr>
+              <a:spcAft>
+                <a:spcPts val="400"/>
+              </a:spcAft>
+            </a:pPr>
+            <a:r>
+              <a:rPr sz="1300" b="0">
+                <a:solidFill>
+                  <a:srgbClr val="1A1A1A"/>
+                </a:solidFill>
+                <a:latin typeface="Calibri"/>
+              </a:rPr>
+              <a:t>Weigert, Alexander, and Bernd Hoppe. Frontiers in Pediatrics, vol. 6, 2018, article 98. https://doi.org/10.3389/fped.2018.00098</a:t>
+            </a:r>
+          </a:p>
+          <a:p>
+            <a:pPr>
+              <a:spcAft>
+                <a:spcPts val="400"/>
+              </a:spcAft>
+            </a:pPr>
+            <a:r>
+              <a:rPr sz="1300" b="0">
+                <a:solidFill>
+                  <a:srgbClr val="1A1A1A"/>
+                </a:solidFill>
+                <a:latin typeface="Calibri"/>
+              </a:rPr>
+              <a:t>Yost, Shawn, et al. Nature Genetics, vol. 49, no. 7, 2017, pp. 1148-51. https://doi.org/10.1038/ng.3883</a:t>
+            </a:r>
+          </a:p>
+          <a:p>
+            <a:pPr>
+              <a:spcAft>
+                <a:spcPts val="400"/>
+              </a:spcAft>
+            </a:pPr>
+            <a:r>
+              <a:rPr sz="1300" b="0">
+                <a:solidFill>
+                  <a:srgbClr val="1A1A1A"/>
+                </a:solidFill>
+                <a:latin typeface="Calibri"/>
+              </a:rPr>
+              <a:t>Zhang, Na, et al. Nature Aging, vol. 3, 2023, pp. 185-201. https://doi.org/10.1038/s43587-023-00361-w</a:t>
+            </a:r>
+          </a:p>
+          <a:p>
+            <a:pPr>
+              <a:spcAft>
+                <a:spcPts val="400"/>
+              </a:spcAft>
+            </a:pPr>
+            <a:r>
+              <a:rPr sz="1300" b="0">
+                <a:solidFill>
+                  <a:srgbClr val="1A1A1A"/>
+                </a:solidFill>
+                <a:latin typeface="Calibri"/>
+              </a:rPr>
+              <a:t>Villarroya-Beltri, Carolina, et al. Science Advances, vol. 8, no. 44, 2022, eabq5914. https://doi.org/10.1126/sciadv.abq5914</a:t>
+            </a:r>
+          </a:p>
+          <a:p>
+            <a:pPr>
+              <a:spcAft>
+                <a:spcPts val="400"/>
+              </a:spcAft>
+            </a:pPr>
+            <a:r>
+              <a:rPr sz="1300" b="0">
+                <a:solidFill>
+                  <a:srgbClr val="1A1A1A"/>
+                </a:solidFill>
+                <a:latin typeface="Calibri"/>
+              </a:rPr>
+              <a:t>Cole, Kristina A., et al. Cancer, vol. 129, no. 14, 2023, pp. 2245-55. https://doi.org/10.1002/cncr.34786</a:t>
+            </a:r>
+          </a:p>
+          <a:p>
+            <a:pPr>
+              <a:spcAft>
+                <a:spcPts val="400"/>
+              </a:spcAft>
+            </a:pPr>
+            <a:r>
+              <a:rPr sz="1300" b="0">
+                <a:solidFill>
+                  <a:srgbClr val="1A1A1A"/>
+                </a:solidFill>
+                <a:latin typeface="Calibri"/>
+              </a:rPr>
+              <a:t>Open Targets. BUB1B ENSG00000156970. https://platform.opentargets.org/target/ENSG00000156970</a:t>
+            </a:r>
+          </a:p>
+          <a:p>
+            <a:pPr>
+              <a:spcAft>
+                <a:spcPts val="400"/>
+              </a:spcAft>
+            </a:pPr>
+            <a:r>
+              <a:rPr sz="1300" b="0">
+                <a:solidFill>
+                  <a:srgbClr val="1A1A1A"/>
+                </a:solidFill>
+                <a:latin typeface="Calibri"/>
+              </a:rPr>
+              <a:t>ClinVar. VCV000533901. https://www.ncbi.nlm.nih.gov/clinvar/variation/533901/</a:t>
+            </a:r>
+          </a:p>
+          <a:p>
+            <a:pPr>
+              <a:spcAft>
+                <a:spcPts val="400"/>
+              </a:spcAft>
+            </a:pPr>
+            <a:r>
+              <a:rPr sz="1300" b="0">
+                <a:solidFill>
+                  <a:srgbClr val="1A1A1A"/>
+                </a:solidFill>
+                <a:latin typeface="Calibri"/>
+              </a:rPr>
+              <a:t>bigbag. mva-hackathon-2026. GitHub. https://github.com/bigbag/mva-hackathon-2026</a:t>
+            </a:r>
+          </a:p>
+        </p:txBody>
+      </p:sp>
+    </p:spTree>
+  </p:cSld>
+  <p:clrMapOvr>
+    <a:masterClrMapping/>
+  </p:clrMapOvr>
+</p:sld>
+</file>
+
+<file path=ppt/slides/slide14.xml><?xml version="1.0" encoding="utf-8"?>
+<p:sld xmlns:a="http://schemas.openxmlformats.org/drawingml/2006/main" xmlns:p="http://schemas.openxmlformats.org/presentationml/2006/main" xmlns:r="http://schemas.openxmlformats.org/officeDocument/2006/relationships">
+  <p:cSld>
+    <p:spTree>
+      <p:nvGrpSpPr>
+        <p:cNvPr id="1" name=""/>
+        <p:cNvGrpSpPr/>
+        <p:nvPr/>
+      </p:nvGrpSpPr>
+      <p:grpSpPr/>
+      <p:sp>
+        <p:nvSpPr>
+          <p:cNvPr id="2" name="TextBox 1"/>
+          <p:cNvSpPr txBox="1"/>
+          <p:nvPr/>
+        </p:nvSpPr>
+        <p:spPr>
+          <a:xfrm>
+            <a:off x="502920" y="256032"/>
+            <a:ext cx="11155680" cy="640080"/>
+          </a:xfrm>
+          <a:prstGeom prst="rect">
+            <a:avLst/>
+          </a:prstGeom>
+          <a:noFill/>
+        </p:spPr>
+        <p:txBody>
+          <a:bodyPr wrap="none">
+            <a:spAutoFit/>
+          </a:bodyPr>
+          <a:lstStyle/>
+          <a:p>
+            <a:pPr algn="l"/>
+            <a:r>
+              <a:rPr sz="2800" b="1">
+                <a:solidFill>
+                  <a:srgbClr val="1E3A5F"/>
+                </a:solidFill>
+                <a:latin typeface="Calibri"/>
+              </a:rPr>
+              <a:t>Thank you</a:t>
+            </a:r>
+          </a:p>
+        </p:txBody>
+      </p:sp>
+      <p:sp>
+        <p:nvSpPr>
+          <p:cNvPr id="3" name="TextBox 2"/>
+          <p:cNvSpPr txBox="1"/>
+          <p:nvPr/>
+        </p:nvSpPr>
+        <p:spPr>
+          <a:xfrm>
+            <a:off x="640080" y="1371600"/>
             <a:ext cx="10881360" cy="4754880"/>
           </a:xfrm>
           <a:prstGeom prst="rect">
@@ -3566,13 +3992,13 @@
               </a:spcAft>
             </a:pPr>
             <a:r>
-              <a:rPr sz="2200" b="0">
+              <a:rPr sz="1800" b="0">
                 <a:solidFill>
                   <a:srgbClr val="1A1A1A"/>
                 </a:solidFill>
                 <a:latin typeface="Calibri"/>
               </a:rPr>
-              <a:t>Team bigbag. github.com/bigbag/mva-hackathon-2026</a:t>
+              <a:t>Team bigbag. https://github.com/bigbag/mva-hackathon-2026</a:t>
             </a:r>
           </a:p>
           <a:p>
@@ -3582,13 +4008,13 @@
               </a:spcAft>
             </a:pPr>
             <a:r>
-              <a:rPr sz="2200" b="0">
+              <a:rPr sz="1800" b="0">
                 <a:solidFill>
                   <a:srgbClr val="1A1A1A"/>
                 </a:solidFill>
                 <a:latin typeface="Calibri"/>
               </a:rPr>
-              <a:t>Organizers: Sage Bionetworks, MVA Society, Hugging Face, BEACON.</a:t>
+              <a:t>Hackathon: https://sagebio-rare-disease-real-kid-mva-hackathon-2026.hf.space/</a:t>
             </a:r>
           </a:p>
           <a:p>
@@ -3598,13 +4024,13 @@
               </a:spcAft>
             </a:pPr>
             <a:r>
-              <a:rPr sz="2200" b="0">
+              <a:rPr sz="1800" b="0">
                 <a:solidFill>
                   <a:srgbClr val="1A1A1A"/>
                 </a:solidFill>
                 <a:latin typeface="Calibri"/>
               </a:rPr>
-              <a:t>Sponsors: AWS and Anthropic.</a:t>
+              <a:t>Data: https://huggingface.co/datasets/SageBio/mva-hackathon-2026-data</a:t>
             </a:r>
           </a:p>
           <a:p>
@@ -3614,7 +4040,23 @@
               </a:spcAft>
             </a:pPr>
             <a:r>
-              <a:rPr sz="2200" b="0">
+              <a:rPr sz="1800" b="0">
+                <a:solidFill>
+                  <a:srgbClr val="1A1A1A"/>
+                </a:solidFill>
+                <a:latin typeface="Calibri"/>
+              </a:rPr>
+              <a:t>Organizers: Sage Bionetworks, MVA Society, Hugging Face, BEACON. Sponsors: AWS and Anthropic.</a:t>
+            </a:r>
+          </a:p>
+          <a:p>
+            <a:pPr>
+              <a:spcAft>
+                <a:spcPts val="1200"/>
+              </a:spcAft>
+            </a:pPr>
+            <a:r>
+              <a:rPr sz="1800" b="0">
                 <a:solidFill>
                   <a:srgbClr val="1A1A1A"/>
                 </a:solidFill>

</xml_diff>

<commit_message>
Point every citation at a title-matched PubMed or official record
Drop guessed PMIDs that resolved to unrelated papers. Keep DOI plus
NCBI-verified PubMed IDs; use the live ChEMBL explore URL.
</commit_message>
<xml_diff>
--- a/track2/slides/pitch_deck.pptx
+++ b/track2/slides/pitch_deck.pptx
@@ -3574,7 +3574,7 @@
                 </a:solidFill>
                 <a:latin typeface="Calibri"/>
               </a:rPr>
-              <a:t>Baker, Darren J., et al. Nature Cell Biology, vol. 15, no. 1, 2013, pp. 96-102. https://doi.org/10.1038/ncb2643</a:t>
+              <a:t>Baker et al. Nat Cell Biol 2013. https://doi.org/10.1038/ncb2643  https://pubmed.ncbi.nlm.nih.gov/23242215/</a:t>
             </a:r>
           </a:p>
           <a:p>
@@ -3590,7 +3590,7 @@
                 </a:solidFill>
                 <a:latin typeface="Calibri"/>
               </a:rPr>
-              <a:t>Franz, David Neal, et al. The Lancet, vol. 381, no. 9861, 2013, pp. 125-32. https://doi.org/10.1016/S0140-6736(12)61134-9</a:t>
+              <a:t>Franz et al. Lancet 2013 EXIST-1. https://doi.org/10.1016/S0140-6736(12)61134-9  https://pubmed.ncbi.nlm.nih.gov/23158522/</a:t>
             </a:r>
           </a:p>
           <a:p>
@@ -3606,7 +3606,7 @@
                 </a:solidFill>
                 <a:latin typeface="Calibri"/>
               </a:rPr>
-              <a:t>Franz, David Neal, et al. PLOS ONE, vol. 11, no. 6, 2016, e0158476. https://doi.org/10.1371/journal.pone.0158476</a:t>
+              <a:t>Franz et al. PLOS ONE 2016 EXIST-1 long-term. https://doi.org/10.1371/journal.pone.0158476  https://pubmed.ncbi.nlm.nih.gov/27351628/</a:t>
             </a:r>
           </a:p>
           <a:p>
@@ -3622,7 +3622,7 @@
                 </a:solidFill>
                 <a:latin typeface="Calibri"/>
               </a:rPr>
-              <a:t>Hanks, Sandra, et al. Nature Genetics, vol. 36, no. 11, 2004, pp. 1159-61. https://doi.org/10.1038/ng1449</a:t>
+              <a:t>Hanks et al. Nat Genet 2004. https://doi.org/10.1038/ng1449  https://pubmed.ncbi.nlm.nih.gov/15475955/</a:t>
             </a:r>
           </a:p>
           <a:p>
@@ -3638,7 +3638,7 @@
                 </a:solidFill>
                 <a:latin typeface="Calibri"/>
               </a:rPr>
-              <a:t>Malumbres, Marcos, and Carolina Villarroya-Beltri. Nature Reviews Genetics, vol. 25, 2024, pp. 864-78. https://doi.org/10.1038/s41576-024-00762-6</a:t>
+              <a:t>Malumbres and Villarroya-Beltri. Nat Rev Genet 2024. https://doi.org/10.1038/s41576-024-00762-6  https://pubmed.ncbi.nlm.nih.gov/39169218/</a:t>
             </a:r>
           </a:p>
           <a:p>
@@ -3654,7 +3654,7 @@
                 </a:solidFill>
                 <a:latin typeface="Calibri"/>
               </a:rPr>
-              <a:t>Mossé, Yaël P., et al. Clinical Cancer Research, vol. 25, no. 11, 2019, pp. 3229-38. https://doi.org/10.1158/1078-0432.CCR-18-2675</a:t>
+              <a:t>Mossé et al. Clin Cancer Res 2019 ADVL0921. https://doi.org/10.1158/1078-0432.CCR-18-2675  https://pubmed.ncbi.nlm.nih.gov/30777875/</a:t>
             </a:r>
           </a:p>
           <a:p>
@@ -3686,7 +3686,7 @@
                 </a:solidFill>
                 <a:latin typeface="Calibri"/>
               </a:rPr>
-              <a:t>Sage Bionetworks. Rare Disease, Real Kid: MVA Hackathon 2026. https://sagebio-rare-disease-real-kid-mva-hackathon-2026.hf.space/</a:t>
+              <a:t>Sage Bionetworks. Hackathon. https://sagebio-rare-disease-real-kid-mva-hackathon-2026.hf.space/</a:t>
             </a:r>
           </a:p>
           <a:p>
@@ -3702,7 +3702,7 @@
                 </a:solidFill>
                 <a:latin typeface="Calibri"/>
               </a:rPr>
-              <a:t>Sage Bionetworks. mva-hackathon-2026-data. https://huggingface.co/datasets/SageBio/mva-hackathon-2026-data</a:t>
+              <a:t>Sage Bionetworks. Data. https://huggingface.co/datasets/SageBio/mva-hackathon-2026-data</a:t>
             </a:r>
           </a:p>
         </p:txBody>
@@ -3794,7 +3794,7 @@
                 </a:solidFill>
                 <a:latin typeface="Calibri"/>
               </a:rPr>
-              <a:t>Weigert, Alexander, and Bernd Hoppe. Frontiers in Pediatrics, vol. 6, 2018, article 98. https://doi.org/10.3389/fped.2018.00098</a:t>
+              <a:t>Weigert and Hoppe. Front Pediatr 2018. https://doi.org/10.3389/fped.2018.00098  https://pubmed.ncbi.nlm.nih.gov/29707529/</a:t>
             </a:r>
           </a:p>
           <a:p>
@@ -3810,7 +3810,7 @@
                 </a:solidFill>
                 <a:latin typeface="Calibri"/>
               </a:rPr>
-              <a:t>Yost, Shawn, et al. Nature Genetics, vol. 49, no. 7, 2017, pp. 1148-51. https://doi.org/10.1038/ng.3883</a:t>
+              <a:t>Yost et al. Nat Genet 2017. https://doi.org/10.1038/ng.3883  https://pubmed.ncbi.nlm.nih.gov/28553959/</a:t>
             </a:r>
           </a:p>
           <a:p>
@@ -3826,7 +3826,7 @@
                 </a:solidFill>
                 <a:latin typeface="Calibri"/>
               </a:rPr>
-              <a:t>Zhang, Na, et al. Nature Aging, vol. 3, 2023, pp. 185-201. https://doi.org/10.1038/s43587-023-00361-w</a:t>
+              <a:t>Zhang et al. Nat Aging 2023. https://doi.org/10.1038/s43587-023-00361-w  https://pubmed.ncbi.nlm.nih.gov/37118121/</a:t>
             </a:r>
           </a:p>
           <a:p>
@@ -3842,7 +3842,7 @@
                 </a:solidFill>
                 <a:latin typeface="Calibri"/>
               </a:rPr>
-              <a:t>Villarroya-Beltri, Carolina, et al. Science Advances, vol. 8, no. 44, 2022, eabq5914. https://doi.org/10.1126/sciadv.abq5914</a:t>
+              <a:t>Villarroya-Beltri et al. Sci Adv 2022. https://doi.org/10.1126/sciadv.abq5914  https://pubmed.ncbi.nlm.nih.gov/36322655/</a:t>
             </a:r>
           </a:p>
           <a:p>
@@ -3858,7 +3858,7 @@
                 </a:solidFill>
                 <a:latin typeface="Calibri"/>
               </a:rPr>
-              <a:t>Cole, Kristina A., et al. Cancer, vol. 129, no. 14, 2023, pp. 2245-55. https://doi.org/10.1002/cncr.34786</a:t>
+              <a:t>Cole et al. Cancer 2023. https://doi.org/10.1002/cncr.34786  https://pubmed.ncbi.nlm.nih.gov/37081608/</a:t>
             </a:r>
           </a:p>
           <a:p>
@@ -3874,7 +3874,7 @@
                 </a:solidFill>
                 <a:latin typeface="Calibri"/>
               </a:rPr>
-              <a:t>Open Targets. BUB1B ENSG00000156970. https://platform.opentargets.org/target/ENSG00000156970</a:t>
+              <a:t>Open Targets. BUB1B. https://platform.opentargets.org/target/ENSG00000156970</a:t>
             </a:r>
           </a:p>
           <a:p>
@@ -3906,7 +3906,7 @@
                 </a:solidFill>
                 <a:latin typeface="Calibri"/>
               </a:rPr>
-              <a:t>bigbag. mva-hackathon-2026. GitHub. https://github.com/bigbag/mva-hackathon-2026</a:t>
+              <a:t>bigbag. Code. https://github.com/bigbag/mva-hackathon-2026</a:t>
             </a:r>
           </a:p>
         </p:txBody>

</xml_diff>

<commit_message>
Attach a verified link to every in-text work mention
No paper, trial, or database name stands without a title-matched URL.
Stenton year corrected to 2022. Orphanet claim removed (no valid page).
</commit_message>
<xml_diff>
--- a/track2/slides/pitch_deck.pptx
+++ b/track2/slides/pitch_deck.pptx
@@ -4492,7 +4492,7 @@
                 </a:solidFill>
                 <a:latin typeface="Calibri"/>
               </a:rPr>
-              <a:t>A pediatric trial sets the dose (NCT02095132). The trial has a rhabdomyosarcoma arm.</a:t>
+              <a:t>A pediatric trial sets the dose. NCT02095132. https://clinicaltrials.gov/study/NCT02095132</a:t>
             </a:r>
           </a:p>
         </p:txBody>
@@ -4557,7 +4557,7 @@
                 </a:solidFill>
                 <a:latin typeface="Calibri"/>
               </a:rPr>
-              <a:t>Standard care for nephrocalcinosis. Safe in children. Protects bone.</a:t>
+              <a:t>Standard care for nephrocalcinosis. Weigert and Hoppe. https://pubmed.ncbi.nlm.nih.gov/29707529/</a:t>
             </a:r>
           </a:p>
         </p:txBody>
@@ -4622,7 +4622,7 @@
                 </a:solidFill>
                 <a:latin typeface="Calibri"/>
               </a:rPr>
-              <a:t>Alternate mitotic drug. COG phase 2 trial ADVL0921.</a:t>
+              <a:t>Alternate mitotic drug. COG ADVL0921. https://pubmed.ncbi.nlm.nih.gov/30777875/</a:t>
             </a:r>
           </a:p>
         </p:txBody>
@@ -4805,7 +4805,7 @@
                 </a:solidFill>
                 <a:latin typeface="Calibri"/>
               </a:rPr>
-              <a:t>Pediatric safety data are large. EXIST-1. Transplant infants.</a:t>
+              <a:t>Pediatric safety data are large. EXIST-1 long-term. https://pubmed.ncbi.nlm.nih.gov/27351628/</a:t>
             </a:r>
           </a:p>
         </p:txBody>
@@ -4988,7 +4988,7 @@
                 </a:solidFill>
                 <a:latin typeface="Calibri"/>
               </a:rPr>
-              <a:t>More BubR1 repairs the checkpoint. More BubR1 extends lifespan.</a:t>
+              <a:t>More BubR1 repairs the checkpoint. https://pubmed.ncbi.nlm.nih.gov/23242215/</a:t>
             </a:r>
           </a:p>
         </p:txBody>

</xml_diff>

<commit_message>
Normalize citations to MLA 9
In-text uses author, not author-year. Works Cited lists only works
named in that document, with NCBI-checked vol/no/pages and a single DOI.
</commit_message>
<xml_diff>
--- a/track2/slides/pitch_deck.pptx
+++ b/track2/slides/pitch_deck.pptx
@@ -3568,13 +3568,13 @@
               </a:spcAft>
             </a:pPr>
             <a:r>
-              <a:rPr sz="1300" b="0">
+              <a:rPr sz="1200" b="0">
                 <a:solidFill>
                   <a:srgbClr val="1A1A1A"/>
                 </a:solidFill>
                 <a:latin typeface="Calibri"/>
               </a:rPr>
-              <a:t>Baker et al. Nat Cell Biol 2013. https://doi.org/10.1038/ncb2643  https://pubmed.ncbi.nlm.nih.gov/23242215/</a:t>
+              <a:t>Baker, Darren J., et al. "Increased Expression of BubR1 Protects against Aneuploidy and Cancer and Extends Healthy Lifespan." Nature Cell Biology, vol. 15, no. 1, 2013, pp. 96-102. https://doi.org/10.1038/ncb2643.</a:t>
             </a:r>
           </a:p>
           <a:p>
@@ -3584,13 +3584,13 @@
               </a:spcAft>
             </a:pPr>
             <a:r>
-              <a:rPr sz="1300" b="0">
+              <a:rPr sz="1200" b="0">
                 <a:solidFill>
                   <a:srgbClr val="1A1A1A"/>
                 </a:solidFill>
                 <a:latin typeface="Calibri"/>
               </a:rPr>
-              <a:t>Franz et al. Lancet 2013 EXIST-1. https://doi.org/10.1016/S0140-6736(12)61134-9  https://pubmed.ncbi.nlm.nih.gov/23158522/</a:t>
+              <a:t>bigbag. "mva-hackathon-2026." GitHub, 2026, https://github.com/bigbag/mva-hackathon-2026.</a:t>
             </a:r>
           </a:p>
           <a:p>
@@ -3600,13 +3600,13 @@
               </a:spcAft>
             </a:pPr>
             <a:r>
-              <a:rPr sz="1300" b="0">
+              <a:rPr sz="1200" b="0">
                 <a:solidFill>
                   <a:srgbClr val="1A1A1A"/>
                 </a:solidFill>
                 <a:latin typeface="Calibri"/>
               </a:rPr>
-              <a:t>Franz et al. PLOS ONE 2016 EXIST-1 long-term. https://doi.org/10.1371/journal.pone.0158476  https://pubmed.ncbi.nlm.nih.gov/27351628/</a:t>
+              <a:t>ChEMBL. "Wee1-like Protein Kinase (CHEMBL5491)." ChEMBL, EMBL-EBI, https://www.ebi.ac.uk/chembl/explore/target/CHEMBL5491.</a:t>
             </a:r>
           </a:p>
           <a:p>
@@ -3616,13 +3616,13 @@
               </a:spcAft>
             </a:pPr>
             <a:r>
-              <a:rPr sz="1300" b="0">
+              <a:rPr sz="1200" b="0">
                 <a:solidFill>
                   <a:srgbClr val="1A1A1A"/>
                 </a:solidFill>
                 <a:latin typeface="Calibri"/>
               </a:rPr>
-              <a:t>Hanks et al. Nat Genet 2004. https://doi.org/10.1038/ng1449  https://pubmed.ncbi.nlm.nih.gov/15475955/</a:t>
+              <a:t>Cole, Kristina A., et al. "Pediatric Phase 2 Trial of a WEE1 Inhibitor, Adavosertib (AZD1775), and Irinotecan for Relapsed Neuroblastoma, Medulloblastoma, and Rhabdomyosarcoma." Cancer, vol. 129, no. 14, 2023, pp. 2245-55. https://doi.org/10.1002/cncr.34786.</a:t>
             </a:r>
           </a:p>
           <a:p>
@@ -3632,13 +3632,13 @@
               </a:spcAft>
             </a:pPr>
             <a:r>
-              <a:rPr sz="1300" b="0">
+              <a:rPr sz="1200" b="0">
                 <a:solidFill>
                   <a:srgbClr val="1A1A1A"/>
                 </a:solidFill>
                 <a:latin typeface="Calibri"/>
               </a:rPr>
-              <a:t>Malumbres and Villarroya-Beltri. Nat Rev Genet 2024. https://doi.org/10.1038/s41576-024-00762-6  https://pubmed.ncbi.nlm.nih.gov/39169218/</a:t>
+              <a:t>DGIdb. The Drug Gene Interaction Database, Washington University School of Medicine, https://www.dgidb.org/.</a:t>
             </a:r>
           </a:p>
           <a:p>
@@ -3648,13 +3648,13 @@
               </a:spcAft>
             </a:pPr>
             <a:r>
-              <a:rPr sz="1300" b="0">
+              <a:rPr sz="1200" b="0">
                 <a:solidFill>
                   <a:srgbClr val="1A1A1A"/>
                 </a:solidFill>
                 <a:latin typeface="Calibri"/>
               </a:rPr>
-              <a:t>Mossé et al. Clin Cancer Res 2019 ADVL0921. https://doi.org/10.1158/1078-0432.CCR-18-2675  https://pubmed.ncbi.nlm.nih.gov/30777875/</a:t>
+              <a:t>everycure. "matrix-scores." Hugging Face, https://huggingface.co/datasets/everycure/matrix-scores.</a:t>
             </a:r>
           </a:p>
           <a:p>
@@ -3664,45 +3664,13 @@
               </a:spcAft>
             </a:pPr>
             <a:r>
-              <a:rPr sz="1300" b="0">
+              <a:rPr sz="1200" b="0">
                 <a:solidFill>
                   <a:srgbClr val="1A1A1A"/>
                 </a:solidFill>
                 <a:latin typeface="Calibri"/>
               </a:rPr>
-              <a:t>National Cancer Institute. NCT02095132. https://clinicaltrials.gov/study/NCT02095132</a:t>
-            </a:r>
-          </a:p>
-          <a:p>
-            <a:pPr>
-              <a:spcAft>
-                <a:spcPts val="400"/>
-              </a:spcAft>
-            </a:pPr>
-            <a:r>
-              <a:rPr sz="1300" b="0">
-                <a:solidFill>
-                  <a:srgbClr val="1A1A1A"/>
-                </a:solidFill>
-                <a:latin typeface="Calibri"/>
-              </a:rPr>
-              <a:t>Sage Bionetworks. Hackathon. https://sagebio-rare-disease-real-kid-mva-hackathon-2026.hf.space/</a:t>
-            </a:r>
-          </a:p>
-          <a:p>
-            <a:pPr>
-              <a:spcAft>
-                <a:spcPts val="400"/>
-              </a:spcAft>
-            </a:pPr>
-            <a:r>
-              <a:rPr sz="1300" b="0">
-                <a:solidFill>
-                  <a:srgbClr val="1A1A1A"/>
-                </a:solidFill>
-                <a:latin typeface="Calibri"/>
-              </a:rPr>
-              <a:t>Sage Bionetworks. Data. https://huggingface.co/datasets/SageBio/mva-hackathon-2026-data</a:t>
+              <a:t>Franz, David Neal, et al. "Long-Term Use of Everolimus in Patients with Tuberous Sclerosis Complex: Final Results from the EXIST-1 Study." PLOS ONE, vol. 11, no. 6, 2016, e0158476. https://doi.org/10.1371/journal.pone.0158476.</a:t>
             </a:r>
           </a:p>
         </p:txBody>
@@ -3788,13 +3756,13 @@
               </a:spcAft>
             </a:pPr>
             <a:r>
-              <a:rPr sz="1300" b="0">
+              <a:rPr sz="1200" b="0">
                 <a:solidFill>
                   <a:srgbClr val="1A1A1A"/>
                 </a:solidFill>
                 <a:latin typeface="Calibri"/>
               </a:rPr>
-              <a:t>Weigert and Hoppe. Front Pediatr 2018. https://doi.org/10.3389/fped.2018.00098  https://pubmed.ncbi.nlm.nih.gov/29707529/</a:t>
+              <a:t>Mossé, Yaël P., et al. "A Phase II Study of Alisertib in Children with Recurrent/Refractory Solid Tumors or Leukemia: Children's Oncology Group Phase I and Pilot Consortium (ADVL0921)." Clinical Cancer Research, vol. 25, no. 11, 2019, pp. 3229-38. https://doi.org/10.1158/1078-0432.CCR-18-2675.</a:t>
             </a:r>
           </a:p>
           <a:p>
@@ -3804,13 +3772,13 @@
               </a:spcAft>
             </a:pPr>
             <a:r>
-              <a:rPr sz="1300" b="0">
+              <a:rPr sz="1200" b="0">
                 <a:solidFill>
                   <a:srgbClr val="1A1A1A"/>
                 </a:solidFill>
                 <a:latin typeface="Calibri"/>
               </a:rPr>
-              <a:t>Yost et al. Nat Genet 2017. https://doi.org/10.1038/ng.3883  https://pubmed.ncbi.nlm.nih.gov/28553959/</a:t>
+              <a:t>National Cancer Institute. "Adavosertib and Irinotecan Hydrochloride in Treating Younger Patients with Relapsed or Refractory Solid Tumors." ClinicalTrials.gov, NCT02095132, U.S. National Library of Medicine, https://clinicaltrials.gov/study/NCT02095132.</a:t>
             </a:r>
           </a:p>
           <a:p>
@@ -3820,13 +3788,13 @@
               </a:spcAft>
             </a:pPr>
             <a:r>
-              <a:rPr sz="1300" b="0">
+              <a:rPr sz="1200" b="0">
                 <a:solidFill>
                   <a:srgbClr val="1A1A1A"/>
                 </a:solidFill>
                 <a:latin typeface="Calibri"/>
               </a:rPr>
-              <a:t>Zhang et al. Nat Aging 2023. https://doi.org/10.1038/s43587-023-00361-w  https://pubmed.ncbi.nlm.nih.gov/37118121/</a:t>
+              <a:t>Open Targets Platform. "BUB1B (ENSG00000156970)." Open Targets, https://platform.opentargets.org/target/ENSG00000156970.</a:t>
             </a:r>
           </a:p>
           <a:p>
@@ -3836,13 +3804,13 @@
               </a:spcAft>
             </a:pPr>
             <a:r>
-              <a:rPr sz="1300" b="0">
+              <a:rPr sz="1200" b="0">
                 <a:solidFill>
                   <a:srgbClr val="1A1A1A"/>
                 </a:solidFill>
                 <a:latin typeface="Calibri"/>
               </a:rPr>
-              <a:t>Villarroya-Beltri et al. Sci Adv 2022. https://doi.org/10.1126/sciadv.abq5914  https://pubmed.ncbi.nlm.nih.gov/36322655/</a:t>
+              <a:t>Sage Bionetworks. "mva-hackathon-2026-data." Hugging Face Datasets, 2026, https://huggingface.co/datasets/SageBio/mva-hackathon-2026-data.</a:t>
             </a:r>
           </a:p>
           <a:p>
@@ -3852,13 +3820,13 @@
               </a:spcAft>
             </a:pPr>
             <a:r>
-              <a:rPr sz="1300" b="0">
+              <a:rPr sz="1200" b="0">
                 <a:solidFill>
                   <a:srgbClr val="1A1A1A"/>
                 </a:solidFill>
                 <a:latin typeface="Calibri"/>
               </a:rPr>
-              <a:t>Cole et al. Cancer 2023. https://doi.org/10.1002/cncr.34786  https://pubmed.ncbi.nlm.nih.gov/37081608/</a:t>
+              <a:t>———. "Rare Disease, Real Kid: MVA Hackathon 2026." Hugging Face Spaces, 2026, https://sagebio-rare-disease-real-kid-mva-hackathon-2026.hf.space/.</a:t>
             </a:r>
           </a:p>
           <a:p>
@@ -3868,13 +3836,13 @@
               </a:spcAft>
             </a:pPr>
             <a:r>
-              <a:rPr sz="1300" b="0">
+              <a:rPr sz="1200" b="0">
                 <a:solidFill>
                   <a:srgbClr val="1A1A1A"/>
                 </a:solidFill>
                 <a:latin typeface="Calibri"/>
               </a:rPr>
-              <a:t>Open Targets. BUB1B. https://platform.opentargets.org/target/ENSG00000156970</a:t>
+              <a:t>Weigert, Alexander, and Bernd Hoppe. "Nephrolithiasis and Nephrocalcinosis in Childhood—Risk Factor-Related Current and Future Treatment Options." Frontiers in Pediatrics, vol. 6, 2018, p. 98. https://doi.org/10.3389/fped.2018.00098.</a:t>
             </a:r>
           </a:p>
           <a:p>
@@ -3884,29 +3852,13 @@
               </a:spcAft>
             </a:pPr>
             <a:r>
-              <a:rPr sz="1300" b="0">
+              <a:rPr sz="1200" b="0">
                 <a:solidFill>
                   <a:srgbClr val="1A1A1A"/>
                 </a:solidFill>
                 <a:latin typeface="Calibri"/>
               </a:rPr>
-              <a:t>ClinVar. VCV000533901. https://www.ncbi.nlm.nih.gov/clinvar/variation/533901/</a:t>
-            </a:r>
-          </a:p>
-          <a:p>
-            <a:pPr>
-              <a:spcAft>
-                <a:spcPts val="400"/>
-              </a:spcAft>
-            </a:pPr>
-            <a:r>
-              <a:rPr sz="1300" b="0">
-                <a:solidFill>
-                  <a:srgbClr val="1A1A1A"/>
-                </a:solidFill>
-                <a:latin typeface="Calibri"/>
-              </a:rPr>
-              <a:t>bigbag. Code. https://github.com/bigbag/mva-hackathon-2026</a:t>
+              <a:t>Zhang, Na, et al. "Unique Progerin C-Terminal Peptide Ameliorates Hutchinson-Gilford Progeria Syndrome Phenotype by Rescuing BUBR1." Nature Aging, vol. 3, no. 2, 2023, pp. 185-201. https://doi.org/10.1038/s43587-023-00361-w.</a:t>
             </a:r>
           </a:p>
         </p:txBody>
@@ -4492,7 +4444,7 @@
                 </a:solidFill>
                 <a:latin typeface="Calibri"/>
               </a:rPr>
-              <a:t>A pediatric trial sets the dose. NCT02095132. https://clinicaltrials.gov/study/NCT02095132</a:t>
+              <a:t>A pediatric trial sets the dose (Cole et al.; National Cancer Institute).</a:t>
             </a:r>
           </a:p>
         </p:txBody>
@@ -4557,7 +4509,7 @@
                 </a:solidFill>
                 <a:latin typeface="Calibri"/>
               </a:rPr>
-              <a:t>Standard care for nephrocalcinosis. Weigert and Hoppe. https://pubmed.ncbi.nlm.nih.gov/29707529/</a:t>
+              <a:t>Standard care for nephrocalcinosis (Weigert and Hoppe). Safe in children. Protects bone.</a:t>
             </a:r>
           </a:p>
         </p:txBody>
@@ -4622,7 +4574,7 @@
                 </a:solidFill>
                 <a:latin typeface="Calibri"/>
               </a:rPr>
-              <a:t>Alternate mitotic drug. COG ADVL0921. https://pubmed.ncbi.nlm.nih.gov/30777875/</a:t>
+              <a:t>Alternate mitotic drug. COG phase 2 trial (Mossé et al.).</a:t>
             </a:r>
           </a:p>
         </p:txBody>
@@ -4805,7 +4757,7 @@
                 </a:solidFill>
                 <a:latin typeface="Calibri"/>
               </a:rPr>
-              <a:t>Pediatric safety data are large. EXIST-1 long-term. https://pubmed.ncbi.nlm.nih.gov/27351628/</a:t>
+              <a:t>Pediatric safety data are large (Franz et al., "Long-Term Use"). Transplant infants.</a:t>
             </a:r>
           </a:p>
         </p:txBody>
@@ -4977,7 +4929,7 @@
                 </a:solidFill>
                 <a:latin typeface="Calibri"/>
               </a:rPr>
-              <a:t>Mouse data (Baker 2013)</a:t>
+              <a:t>Mouse data (Baker et al.)</a:t>
             </a:r>
           </a:p>
           <a:p>
@@ -4988,7 +4940,7 @@
                 </a:solidFill>
                 <a:latin typeface="Calibri"/>
               </a:rPr>
-              <a:t>More BubR1 repairs the checkpoint. https://pubmed.ncbi.nlm.nih.gov/23242215/</a:t>
+              <a:t>More BubR1 repairs the checkpoint. https://doi.org/10.1038/ncb2643</a:t>
             </a:r>
           </a:p>
         </p:txBody>
@@ -5118,7 +5070,7 @@
                 </a:solidFill>
                 <a:latin typeface="Calibri"/>
               </a:rPr>
-              <a:t>AAV gene augmentation. SIRT2-axis stabilization. Peptide rescue.</a:t>
+              <a:t>AAV gene augmentation. SIRT2-axis stabilization. Peptide rescue (Zhang et al.).</a:t>
             </a:r>
           </a:p>
         </p:txBody>

</xml_diff>

<commit_message>
Link every work name to its verified record
EXIST-1, RepoDB, Reactome, VEP, Exomiser, AlphaMissense, and SpliceAI
now carry the same URL as the Works Cited entry they point to.
</commit_message>
<xml_diff>
--- a/track2/slides/pitch_deck.pptx
+++ b/track2/slides/pitch_deck.pptx
@@ -3294,7 +3294,7 @@
                 </a:solidFill>
                 <a:latin typeface="Calibri"/>
               </a:rPr>
-              <a:t>Open Targets. DGIdb. ChEMBL. everycure/matrix-scores (39.5 million pairs). All public APIs.</a:t>
+              <a:t>Open Targets https://platform.opentargets.org/target/ENSG00000156970. DGIdb https://www.dgidb.org/. ChEMBL https://www.ebi.ac.uk/chembl/explore/target/CHEMBL5491. everycure/matrix-scores https://huggingface.co/datasets/everycure/matrix-scores.</a:t>
             </a:r>
           </a:p>
           <a:p>
@@ -3342,7 +3342,7 @@
                 </a:solidFill>
                 <a:latin typeface="Calibri"/>
               </a:rPr>
-              <a:t>Code and evidence: github.com/bigbag/mva-hackathon-2026</a:t>
+              <a:t>Code: https://github.com/bigbag/mva-hackathon-2026</a:t>
             </a:r>
           </a:p>
         </p:txBody>
@@ -4444,7 +4444,7 @@
                 </a:solidFill>
                 <a:latin typeface="Calibri"/>
               </a:rPr>
-              <a:t>A pediatric trial sets the dose (Cole et al.; National Cancer Institute).</a:t>
+              <a:t>Cole et al. https://doi.org/10.1002/cncr.34786. National Cancer Institute https://clinicaltrials.gov/study/NCT02095132.</a:t>
             </a:r>
           </a:p>
         </p:txBody>
@@ -4509,7 +4509,7 @@
                 </a:solidFill>
                 <a:latin typeface="Calibri"/>
               </a:rPr>
-              <a:t>Standard care for nephrocalcinosis (Weigert and Hoppe). Safe in children. Protects bone.</a:t>
+              <a:t>Weigert and Hoppe. https://doi.org/10.3389/fped.2018.00098. Safe in children. Protects bone.</a:t>
             </a:r>
           </a:p>
         </p:txBody>
@@ -4574,7 +4574,7 @@
                 </a:solidFill>
                 <a:latin typeface="Calibri"/>
               </a:rPr>
-              <a:t>Alternate mitotic drug. COG phase 2 trial (Mossé et al.).</a:t>
+              <a:t>Mossé et al. https://doi.org/10.1158/1078-0432.CCR-18-2675.</a:t>
             </a:r>
           </a:p>
         </p:txBody>
@@ -4757,7 +4757,7 @@
                 </a:solidFill>
                 <a:latin typeface="Calibri"/>
               </a:rPr>
-              <a:t>Pediatric safety data are large (Franz et al., "Long-Term Use"). Transplant infants.</a:t>
+              <a:t>Franz et al. https://doi.org/10.1371/journal.pone.0158476.</a:t>
             </a:r>
           </a:p>
         </p:txBody>
@@ -5070,7 +5070,7 @@
                 </a:solidFill>
                 <a:latin typeface="Calibri"/>
               </a:rPr>
-              <a:t>AAV gene augmentation. SIRT2-axis stabilization. Peptide rescue (Zhang et al.).</a:t>
+              <a:t>AAV. SIRT2-axis. Peptide rescue. Zhang et al. https://doi.org/10.1038/s43587-023-00361-w.</a:t>
             </a:r>
           </a:p>
         </p:txBody>

</xml_diff>